<commit_message>
Add Who We Are at a Glance as Appendix A1
User-supplied slide rebuilt in the deck idiom and inserted as first
appendix; A1-A14 shifted to A2-A15 with pages and cross-references
updated. Exports regenerated (26-slide master, 15-page executive).

Co-Authored-By: Claude Fable 5 <noreply@anthropic.com>
Claude-Session: https://claude.ai/code/session_01DUeyPCeDvcPsyTcH6oQXEK
</commit_message>
<xml_diff>
--- a/teaser-rework/Southwire_NRG_Protecting_Time_to_Power_Rev17.pptx
+++ b/teaser-rework/Southwire_NRG_Protecting_Time_to_Power_Rev17.pptx
@@ -16,6 +16,7 @@
     <p:sldId id="264" r:id="rId10"/>
     <p:sldId id="265" r:id="rId11"/>
     <p:sldId id="266" r:id="rId12"/>
+    <p:sldId id="281" r:id="rId32"/>
     <p:sldId id="267" r:id="rId13"/>
     <p:sldId id="268" r:id="rId14"/>
     <p:sldId id="269" r:id="rId15"/>
@@ -6385,7 +6386,7 @@
                 <a:ea typeface="Arial"/>
                 <a:cs typeface="Arial"/>
               </a:rPr>
-              <a:t>APPENDIX A1 · NRG CONTEXT</a:t>
+              <a:t>APPENDIX A2 · NRG CONTEXT</a:t>
             </a:r>
           </a:p>
         </p:txBody>
@@ -6447,7 +6448,7 @@
                 <a:ea typeface="Arial"/>
                 <a:cs typeface="Arial"/>
               </a:rPr>
-              <a:t>12</a:t>
+              <a:t>13</a:t>
             </a:r>
           </a:p>
         </p:txBody>
@@ -7397,7 +7398,7 @@
                 <a:ea typeface="Arial"/>
                 <a:cs typeface="Arial"/>
               </a:rPr>
-              <a:t>APPENDIX A2 · GOVERNANCE</a:t>
+              <a:t>APPENDIX A3 · GOVERNANCE</a:t>
             </a:r>
           </a:p>
         </p:txBody>
@@ -7459,7 +7460,7 @@
                 <a:ea typeface="Arial"/>
                 <a:cs typeface="Arial"/>
               </a:rPr>
-              <a:t>13</a:t>
+              <a:t>14</a:t>
             </a:r>
           </a:p>
         </p:txBody>
@@ -8577,7 +8578,7 @@
                 <a:ea typeface="Arial"/>
                 <a:cs typeface="Arial"/>
               </a:rPr>
-              <a:t>APPENDIX A3 · SOUTHWIRE SUPPORT</a:t>
+              <a:t>APPENDIX A4 · SOUTHWIRE SUPPORT</a:t>
             </a:r>
           </a:p>
         </p:txBody>
@@ -8625,7 +8626,7 @@
                 <a:ea typeface="Arial"/>
                 <a:cs typeface="Arial"/>
               </a:rPr>
-              <a:t>14</a:t>
+              <a:t>15</a:t>
             </a:r>
           </a:p>
         </p:txBody>
@@ -9660,7 +9661,7 @@
                 <a:ea typeface="Arial"/>
                 <a:cs typeface="Arial"/>
               </a:rPr>
-              <a:t>APPENDIX A4 · EVIDENCE DISCIPLINE</a:t>
+              <a:t>APPENDIX A5 · EVIDENCE DISCIPLINE</a:t>
             </a:r>
           </a:p>
         </p:txBody>
@@ -9708,7 +9709,7 @@
                 <a:ea typeface="Arial"/>
                 <a:cs typeface="Arial"/>
               </a:rPr>
-              <a:t>15</a:t>
+              <a:t>16</a:t>
             </a:r>
           </a:p>
         </p:txBody>
@@ -10632,7 +10633,7 @@
                 <a:ea typeface="Arial"/>
                 <a:cs typeface="Arial"/>
               </a:rPr>
-              <a:t>APPENDIX A5 · SITE-MODEL BASIS</a:t>
+              <a:t>APPENDIX A6 · SITE-MODEL BASIS</a:t>
             </a:r>
           </a:p>
         </p:txBody>
@@ -10680,7 +10681,7 @@
                 <a:ea typeface="Arial"/>
                 <a:cs typeface="Arial"/>
               </a:rPr>
-              <a:t>16</a:t>
+              <a:t>17</a:t>
             </a:r>
           </a:p>
         </p:txBody>
@@ -11475,7 +11476,7 @@
                 <a:ea typeface="Arial"/>
                 <a:cs typeface="Arial"/>
               </a:rPr>
-              <a:t>APPENDIX A6 · SK-120 REFERENCE</a:t>
+              <a:t>APPENDIX A7 · SK-120 REFERENCE</a:t>
             </a:r>
           </a:p>
         </p:txBody>
@@ -11523,7 +11524,7 @@
                 <a:ea typeface="Arial"/>
                 <a:cs typeface="Arial"/>
               </a:rPr>
-              <a:t>17</a:t>
+              <a:t>18</a:t>
             </a:r>
           </a:p>
         </p:txBody>
@@ -11735,7 +11736,7 @@
                 <a:ea typeface="Arial"/>
                 <a:cs typeface="Arial"/>
               </a:rPr>
-              <a:t>APPENDIX A7 · SKID SCENARIO</a:t>
+              <a:t>APPENDIX A8 · SKID SCENARIO</a:t>
             </a:r>
           </a:p>
         </p:txBody>
@@ -11797,7 +11798,7 @@
                 <a:ea typeface="Arial"/>
                 <a:cs typeface="Arial"/>
               </a:rPr>
-              <a:t>18</a:t>
+              <a:t>19</a:t>
             </a:r>
           </a:p>
         </p:txBody>
@@ -12839,7 +12840,7 @@
                 <a:ea typeface="Arial"/>
                 <a:cs typeface="Arial"/>
               </a:rPr>
-              <a:t>APPENDIX A8 · ADVANCED CONDUCTOR</a:t>
+              <a:t>APPENDIX A9 · ADVANCED CONDUCTOR</a:t>
             </a:r>
           </a:p>
         </p:txBody>
@@ -12901,7 +12902,7 @@
                 <a:ea typeface="Arial"/>
                 <a:cs typeface="Arial"/>
               </a:rPr>
-              <a:t>19</a:t>
+              <a:t>20</a:t>
             </a:r>
           </a:p>
         </p:txBody>
@@ -15290,7 +15291,7 @@
                 <a:ea typeface="Arial"/>
                 <a:cs typeface="Arial"/>
               </a:rPr>
-              <a:t>APPENDIX A9 · DEPLOYMENT MODES</a:t>
+              <a:t>APPENDIX A10 · DEPLOYMENT MODES</a:t>
             </a:r>
           </a:p>
         </p:txBody>
@@ -15338,7 +15339,7 @@
                 <a:ea typeface="Arial"/>
                 <a:cs typeface="Arial"/>
               </a:rPr>
-              <a:t>20</a:t>
+              <a:t>21</a:t>
             </a:r>
           </a:p>
         </p:txBody>
@@ -16085,7 +16086,7 @@
                 <a:ea typeface="Arial"/>
                 <a:cs typeface="Arial"/>
               </a:rPr>
-              <a:t>APPENDIX A10 · PROJECT OF INTEREST</a:t>
+              <a:t>APPENDIX A11 · PROJECT OF INTEREST</a:t>
             </a:r>
           </a:p>
         </p:txBody>
@@ -16133,7 +16134,7 @@
                 <a:ea typeface="Arial"/>
                 <a:cs typeface="Arial"/>
               </a:rPr>
-              <a:t>21</a:t>
+              <a:t>22</a:t>
             </a:r>
           </a:p>
         </p:txBody>
@@ -17519,7 +17520,7 @@
                 <a:ea typeface="Arial"/>
                 <a:cs typeface="Arial"/>
               </a:rPr>
-              <a:t>APPENDIX A11 · FINANCE + ESG</a:t>
+              <a:t>APPENDIX A12 · FINANCE + ESG</a:t>
             </a:r>
           </a:p>
         </p:txBody>
@@ -17567,7 +17568,7 @@
                 <a:ea typeface="Arial"/>
                 <a:cs typeface="Arial"/>
               </a:rPr>
-              <a:t>22</a:t>
+              <a:t>23</a:t>
             </a:r>
           </a:p>
         </p:txBody>
@@ -18777,7 +18778,7 @@
                 <a:ea typeface="Arial"/>
                 <a:cs typeface="Arial"/>
               </a:rPr>
-              <a:t>APPENDIX A12 · CABLE PLATFORM</a:t>
+              <a:t>APPENDIX A13 · CABLE PLATFORM</a:t>
             </a:r>
           </a:p>
         </p:txBody>
@@ -18825,7 +18826,7 @@
                 <a:ea typeface="Arial"/>
                 <a:cs typeface="Arial"/>
               </a:rPr>
-              <a:t>23</a:t>
+              <a:t>24</a:t>
             </a:r>
           </a:p>
         </p:txBody>
@@ -20217,7 +20218,7 @@
                 <a:ea typeface="Arial"/>
                 <a:cs typeface="Arial"/>
               </a:rPr>
-              <a:t>APPENDIX A13 · OPERATING FLEET</a:t>
+              <a:t>APPENDIX A14 · OPERATING FLEET</a:t>
             </a:r>
           </a:p>
         </p:txBody>
@@ -20265,7 +20266,7 @@
                 <a:ea typeface="Arial"/>
                 <a:cs typeface="Arial"/>
               </a:rPr>
-              <a:t>24</a:t>
+              <a:t>25</a:t>
             </a:r>
           </a:p>
         </p:txBody>
@@ -21387,7 +21388,7 @@
                 <a:ea typeface="Arial"/>
                 <a:cs typeface="Arial"/>
               </a:rPr>
-              <a:t>APPENDIX A14 · BENCHMARK MATH</a:t>
+              <a:t>APPENDIX A15 · BENCHMARK MATH</a:t>
             </a:r>
           </a:p>
         </p:txBody>
@@ -21435,7 +21436,7 @@
                 <a:ea typeface="Arial"/>
                 <a:cs typeface="Arial"/>
               </a:rPr>
-              <a:t>25</a:t>
+              <a:t>26</a:t>
             </a:r>
           </a:p>
         </p:txBody>
@@ -21579,7 +21580,7 @@
                 <a:ea typeface="Arial"/>
                 <a:cs typeface="Arial"/>
               </a:rPr>
-              <a:t>The arithmetic behind slide 9, at a $95/hr fully burdened field-labor rate. This is the template A4 requires to be rebuilt with NRG inputs — not a result.</a:t>
+              <a:t>The arithmetic behind slide 9, at a $95/hr fully burdened field-labor rate. This is the template A5 requires to be rebuilt with NRG inputs — not a result.</a:t>
             </a:r>
           </a:p>
         </p:txBody>
@@ -22739,7 +22740,2449 @@
                 <a:ea typeface="Arial"/>
                 <a:cs typeface="Arial"/>
               </a:rPr>
-              <a:t>GROSS TEMPLATE ONLY — REBUILD WITH NRG SCOPE, LABOR RATES AND SCHEDULE LOGIC BEFORE ANY CLAIM (SEE A4).</a:t>
+              <a:t>GROSS TEMPLATE ONLY — REBUILD WITH NRG SCOPE, LABOR RATES AND SCHEDULE LOGIC BEFORE ANY CLAIM (SEE A5).</a:t>
+            </a:r>
+          </a:p>
+        </p:txBody>
+      </p:sp>
+    </p:spTree>
+  </p:cSld>
+</p:sld>
+</file>
+
+<file path=ppt/slides/slide26.xml><?xml version="1.0" encoding="utf-8"?>
+<p:sld xmlns:p="http://schemas.openxmlformats.org/presentationml/2006/main" xmlns:a="http://schemas.openxmlformats.org/drawingml/2006/main" xmlns:r="http://schemas.openxmlformats.org/officeDocument/2006/relationships">
+  <p:cSld>
+    <p:bg>
+      <p:bgPr>
+        <a:solidFill>
+          <a:srgbClr val="F6F3EE"/>
+        </a:solidFill>
+      </p:bgPr>
+    </p:bg>
+    <p:spTree>
+      <p:nvGrpSpPr>
+        <p:cNvPr id="1" name=""/>
+        <p:cNvGrpSpPr/>
+        <p:nvPr/>
+      </p:nvGrpSpPr>
+      <p:grpSpPr>
+        <a:xfrm/>
+      </p:grpSpPr>
+      <p:sp>
+        <p:nvSpPr>
+          <p:cNvPr id="101" name=""/>
+          <p:cNvSpPr>
+            <a:spLocks noGrp="1"/>
+          </p:cNvSpPr>
+          <p:nvPr/>
+        </p:nvSpPr>
+        <p:spPr>
+          <a:xfrm>
+            <a:off x="0" y="0"/>
+            <a:ext cx="12192000" cy="57150"/>
+          </a:xfrm>
+          <a:prstGeom prst="rect">
+            <a:avLst/>
+          </a:prstGeom>
+          <a:solidFill>
+            <a:srgbClr val="C9783E"/>
+          </a:solidFill>
+          <a:ln w="0">
+            <a:noFill/>
+            <a:prstDash val="solid"/>
+          </a:ln>
+        </p:spPr>
+      </p:sp>
+      <p:pic>
+        <p:nvPicPr>
+          <p:cNvPr id="102" name=""/>
+          <p:cNvPicPr>
+            <a:picLocks noChangeAspect="1"/>
+          </p:cNvPicPr>
+          <p:nvPr/>
+        </p:nvPicPr>
+        <p:blipFill>
+          <a:blip r:embed="rId1"/>
+          <a:stretch/>
+        </p:blipFill>
+        <p:spPr>
+          <a:xfrm>
+            <a:off x="719138" y="200025"/>
+            <a:ext cx="2066925" cy="590550"/>
+          </a:xfrm>
+          <a:prstGeom prst="rect">
+            <a:avLst/>
+          </a:prstGeom>
+        </p:spPr>
+      </p:pic>
+      <p:sp>
+        <p:nvSpPr>
+          <p:cNvPr id="103" name=""/>
+          <p:cNvSpPr>
+            <a:spLocks noGrp="1"/>
+          </p:cNvSpPr>
+          <p:nvPr/>
+        </p:nvSpPr>
+        <p:spPr>
+          <a:xfrm>
+            <a:off x="7325360" y="323850"/>
+            <a:ext cx="3600000" cy="228600"/>
+          </a:xfrm>
+          <a:prstGeom prst="rect">
+            <a:avLst/>
+          </a:prstGeom>
+          <a:noFill/>
+          <a:ln w="0">
+            <a:noFill/>
+            <a:prstDash val="solid"/>
+          </a:ln>
+        </p:spPr>
+        <p:txBody>
+          <a:bodyPr wrap="square" lIns="0" tIns="0" rIns="0" bIns="0" anchor="t">
+            <a:normAutofit fontScale="100000"/>
+          </a:bodyPr>
+          <a:lstStyle/>
+          <a:p>
+            <a:pPr algn="r">
+              <a:lnSpc>
+                <a:spcPct val="100000"/>
+              </a:lnSpc>
+              <a:buNone/>
+            </a:pPr>
+            <a:r>
+              <a:rPr sz="820" b="1" i="0">
+                <a:solidFill>
+                  <a:srgbClr val="9D4E24"/>
+                </a:solidFill>
+                <a:latin typeface="Arial"/>
+                <a:ea typeface="Arial"/>
+                <a:cs typeface="Arial"/>
+              </a:rPr>
+              <a:t>APPENDIX A1 · WHO WE ARE</a:t>
+            </a:r>
+          </a:p>
+        </p:txBody>
+      </p:sp>
+      <p:sp>
+        <p:nvSpPr>
+          <p:cNvPr id="104" name=""/>
+          <p:cNvSpPr>
+            <a:spLocks noGrp="1"/>
+          </p:cNvSpPr>
+          <p:nvPr/>
+        </p:nvSpPr>
+        <p:spPr>
+          <a:xfrm>
+            <a:off x="11060000" y="323850"/>
+            <a:ext cx="600000" cy="228600"/>
+          </a:xfrm>
+          <a:prstGeom prst="rect">
+            <a:avLst/>
+          </a:prstGeom>
+          <a:noFill/>
+          <a:ln w="0">
+            <a:noFill/>
+            <a:prstDash val="solid"/>
+          </a:ln>
+        </p:spPr>
+        <p:txBody>
+          <a:bodyPr wrap="square" lIns="0" tIns="0" rIns="0" bIns="0" anchor="t">
+            <a:normAutofit fontScale="100000"/>
+          </a:bodyPr>
+          <a:lstStyle/>
+          <a:p>
+            <a:pPr algn="r">
+              <a:lnSpc>
+                <a:spcPct val="100000"/>
+              </a:lnSpc>
+              <a:buNone/>
+            </a:pPr>
+            <a:r>
+              <a:rPr sz="820" b="1" i="0">
+                <a:solidFill>
+                  <a:srgbClr val="8B9094"/>
+                </a:solidFill>
+                <a:latin typeface="Arial"/>
+                <a:ea typeface="Arial"/>
+                <a:cs typeface="Arial"/>
+              </a:rPr>
+              <a:t>12</a:t>
+            </a:r>
+          </a:p>
+        </p:txBody>
+      </p:sp>
+      <p:sp>
+        <p:nvSpPr>
+          <p:cNvPr id="105" name=""/>
+          <p:cNvSpPr>
+            <a:spLocks noGrp="1"/>
+          </p:cNvSpPr>
+          <p:nvPr/>
+        </p:nvSpPr>
+        <p:spPr>
+          <a:xfrm>
+            <a:off x="719138" y="1005840"/>
+            <a:ext cx="10753724" cy="228600"/>
+          </a:xfrm>
+          <a:prstGeom prst="rect">
+            <a:avLst/>
+          </a:prstGeom>
+          <a:noFill/>
+          <a:ln w="0">
+            <a:noFill/>
+            <a:prstDash val="solid"/>
+          </a:ln>
+        </p:spPr>
+        <p:txBody>
+          <a:bodyPr wrap="square" lIns="0" tIns="0" rIns="0" bIns="0" anchor="t">
+            <a:normAutofit fontScale="100000"/>
+          </a:bodyPr>
+          <a:lstStyle/>
+          <a:p>
+            <a:pPr algn="l">
+              <a:lnSpc>
+                <a:spcPct val="100000"/>
+              </a:lnSpc>
+              <a:buNone/>
+            </a:pPr>
+            <a:r>
+              <a:rPr sz="880" b="1" i="0">
+                <a:solidFill>
+                  <a:srgbClr val="C9783E"/>
+                </a:solidFill>
+                <a:latin typeface="Arial"/>
+                <a:ea typeface="Arial"/>
+                <a:cs typeface="Arial"/>
+              </a:rPr>
+              <a:t>SOUTHWIRE AT A GLANCE  ·  PUBLISHED FIGURES · 2025 REVENUE PER FORBES 2026</a:t>
+            </a:r>
+          </a:p>
+        </p:txBody>
+      </p:sp>
+      <p:sp>
+        <p:nvSpPr>
+          <p:cNvPr id="106" name=""/>
+          <p:cNvSpPr>
+            <a:spLocks noGrp="1"/>
+          </p:cNvSpPr>
+          <p:nvPr/>
+        </p:nvSpPr>
+        <p:spPr>
+          <a:xfrm>
+            <a:off x="719138" y="1280160"/>
+            <a:ext cx="10753724" cy="500000"/>
+          </a:xfrm>
+          <a:prstGeom prst="rect">
+            <a:avLst/>
+          </a:prstGeom>
+          <a:noFill/>
+          <a:ln w="0">
+            <a:noFill/>
+            <a:prstDash val="solid"/>
+          </a:ln>
+        </p:spPr>
+        <p:txBody>
+          <a:bodyPr wrap="square" lIns="0" tIns="0" rIns="0" bIns="0" anchor="t">
+            <a:normAutofit fontScale="100000"/>
+          </a:bodyPr>
+          <a:lstStyle/>
+          <a:p>
+            <a:pPr algn="l">
+              <a:lnSpc>
+                <a:spcPct val="104000"/>
+              </a:lnSpc>
+              <a:buNone/>
+            </a:pPr>
+            <a:r>
+              <a:rPr sz="2850" b="1" i="0">
+                <a:solidFill>
+                  <a:srgbClr val="17191C"/>
+                </a:solidFill>
+                <a:latin typeface="Arial"/>
+                <a:ea typeface="Arial"/>
+                <a:cs typeface="Arial"/>
+              </a:rPr>
+              <a:t>A family-held American manufacturer, founded in 1950.</a:t>
+            </a:r>
+          </a:p>
+        </p:txBody>
+      </p:sp>
+      <p:sp>
+        <p:nvSpPr>
+          <p:cNvPr id="107" name=""/>
+          <p:cNvSpPr>
+            <a:spLocks noGrp="1"/>
+          </p:cNvSpPr>
+          <p:nvPr/>
+        </p:nvSpPr>
+        <p:spPr>
+          <a:xfrm>
+            <a:off x="719138" y="1874520"/>
+            <a:ext cx="10753724" cy="500000"/>
+          </a:xfrm>
+          <a:prstGeom prst="rect">
+            <a:avLst/>
+          </a:prstGeom>
+          <a:noFill/>
+          <a:ln w="0">
+            <a:noFill/>
+            <a:prstDash val="solid"/>
+          </a:ln>
+        </p:spPr>
+        <p:txBody>
+          <a:bodyPr wrap="square" lIns="0" tIns="0" rIns="0" bIns="0" anchor="t">
+            <a:normAutofit fontScale="100000"/>
+          </a:bodyPr>
+          <a:lstStyle/>
+          <a:p>
+            <a:pPr algn="l">
+              <a:lnSpc>
+                <a:spcPct val="108000"/>
+              </a:lnSpc>
+              <a:buNone/>
+            </a:pPr>
+            <a:r>
+              <a:rPr sz="975" b="0" i="0">
+                <a:solidFill>
+                  <a:srgbClr val="6A6F73"/>
+                </a:solidFill>
+                <a:latin typeface="Arial"/>
+                <a:ea typeface="Arial"/>
+                <a:cs typeface="Arial"/>
+              </a:rPr>
+              <a:t>Roy Richards founded Southwire after the poles his crews built stood wireless for months after World War II. Starting with 12 employees and three secondhand machines in Carrollton, Georgia, Southwire remains family-held and vertically integrated — from copper rod through finished cable.</a:t>
+            </a:r>
+          </a:p>
+        </p:txBody>
+      </p:sp>
+      <p:sp>
+        <p:nvSpPr>
+          <p:cNvPr id="108" name=""/>
+          <p:cNvSpPr>
+            <a:spLocks noGrp="1"/>
+          </p:cNvSpPr>
+          <p:nvPr/>
+        </p:nvSpPr>
+        <p:spPr>
+          <a:xfrm>
+            <a:off x="719138" y="2560320"/>
+            <a:ext cx="2004340" cy="800100"/>
+          </a:xfrm>
+          <a:prstGeom prst="rect">
+            <a:avLst/>
+          </a:prstGeom>
+          <a:solidFill>
+            <a:srgbClr val="FFFFFF"/>
+          </a:solidFill>
+          <a:ln w="9525">
+            <a:solidFill>
+              <a:srgbClr val="D8D1C8"/>
+            </a:solidFill>
+            <a:prstDash val="solid"/>
+          </a:ln>
+        </p:spPr>
+      </p:sp>
+      <p:sp>
+        <p:nvSpPr>
+          <p:cNvPr id="109" name=""/>
+          <p:cNvSpPr>
+            <a:spLocks noGrp="1"/>
+          </p:cNvSpPr>
+          <p:nvPr/>
+        </p:nvSpPr>
+        <p:spPr>
+          <a:xfrm>
+            <a:off x="879158" y="2683510"/>
+            <a:ext cx="1684300" cy="411480"/>
+          </a:xfrm>
+          <a:prstGeom prst="rect">
+            <a:avLst/>
+          </a:prstGeom>
+          <a:noFill/>
+          <a:ln w="0">
+            <a:noFill/>
+            <a:prstDash val="solid"/>
+          </a:ln>
+        </p:spPr>
+        <p:txBody>
+          <a:bodyPr wrap="square" lIns="0" tIns="0" rIns="0" bIns="0" anchor="t">
+            <a:normAutofit fontScale="100000"/>
+          </a:bodyPr>
+          <a:lstStyle/>
+          <a:p>
+            <a:pPr algn="l">
+              <a:lnSpc>
+                <a:spcPct val="100000"/>
+              </a:lnSpc>
+              <a:buNone/>
+            </a:pPr>
+            <a:r>
+              <a:rPr sz="1900" b="1" i="0">
+                <a:solidFill>
+                  <a:srgbClr val="9D4E24"/>
+                </a:solidFill>
+                <a:latin typeface="Arial"/>
+                <a:ea typeface="Arial"/>
+                <a:cs typeface="Arial"/>
+              </a:rPr>
+              <a:t>1950</a:t>
+            </a:r>
+          </a:p>
+        </p:txBody>
+      </p:sp>
+      <p:sp>
+        <p:nvSpPr>
+          <p:cNvPr id="110" name=""/>
+          <p:cNvSpPr>
+            <a:spLocks noGrp="1"/>
+          </p:cNvSpPr>
+          <p:nvPr/>
+        </p:nvSpPr>
+        <p:spPr>
+          <a:xfrm>
+            <a:off x="879158" y="3106420"/>
+            <a:ext cx="1684300" cy="200000"/>
+          </a:xfrm>
+          <a:prstGeom prst="rect">
+            <a:avLst/>
+          </a:prstGeom>
+          <a:noFill/>
+          <a:ln w="0">
+            <a:noFill/>
+            <a:prstDash val="solid"/>
+          </a:ln>
+        </p:spPr>
+        <p:txBody>
+          <a:bodyPr wrap="square" lIns="0" tIns="0" rIns="0" bIns="0" anchor="t">
+            <a:normAutofit fontScale="100000"/>
+          </a:bodyPr>
+          <a:lstStyle/>
+          <a:p>
+            <a:pPr algn="l">
+              <a:lnSpc>
+                <a:spcPct val="100000"/>
+              </a:lnSpc>
+              <a:buNone/>
+            </a:pPr>
+            <a:r>
+              <a:rPr sz="700" b="1" i="0">
+                <a:solidFill>
+                  <a:srgbClr val="6A6F73"/>
+                </a:solidFill>
+                <a:latin typeface="Arial"/>
+                <a:ea typeface="Arial"/>
+                <a:cs typeface="Arial"/>
+              </a:rPr>
+              <a:t>FOUNDED · CARROLLTON, GA</a:t>
+            </a:r>
+          </a:p>
+        </p:txBody>
+      </p:sp>
+      <p:sp>
+        <p:nvSpPr>
+          <p:cNvPr id="111" name=""/>
+          <p:cNvSpPr>
+            <a:spLocks noGrp="1"/>
+          </p:cNvSpPr>
+          <p:nvPr/>
+        </p:nvSpPr>
+        <p:spPr>
+          <a:xfrm>
+            <a:off x="2906484" y="2560320"/>
+            <a:ext cx="2004340" cy="800100"/>
+          </a:xfrm>
+          <a:prstGeom prst="rect">
+            <a:avLst/>
+          </a:prstGeom>
+          <a:solidFill>
+            <a:srgbClr val="FFFFFF"/>
+          </a:solidFill>
+          <a:ln w="9525">
+            <a:solidFill>
+              <a:srgbClr val="D8D1C8"/>
+            </a:solidFill>
+            <a:prstDash val="solid"/>
+          </a:ln>
+        </p:spPr>
+      </p:sp>
+      <p:sp>
+        <p:nvSpPr>
+          <p:cNvPr id="112" name=""/>
+          <p:cNvSpPr>
+            <a:spLocks noGrp="1"/>
+          </p:cNvSpPr>
+          <p:nvPr/>
+        </p:nvSpPr>
+        <p:spPr>
+          <a:xfrm>
+            <a:off x="3066504" y="2683510"/>
+            <a:ext cx="1684300" cy="411480"/>
+          </a:xfrm>
+          <a:prstGeom prst="rect">
+            <a:avLst/>
+          </a:prstGeom>
+          <a:noFill/>
+          <a:ln w="0">
+            <a:noFill/>
+            <a:prstDash val="solid"/>
+          </a:ln>
+        </p:spPr>
+        <p:txBody>
+          <a:bodyPr wrap="square" lIns="0" tIns="0" rIns="0" bIns="0" anchor="t">
+            <a:normAutofit fontScale="100000"/>
+          </a:bodyPr>
+          <a:lstStyle/>
+          <a:p>
+            <a:pPr algn="l">
+              <a:lnSpc>
+                <a:spcPct val="100000"/>
+              </a:lnSpc>
+              <a:buNone/>
+            </a:pPr>
+            <a:r>
+              <a:rPr sz="1900" b="1" i="0">
+                <a:solidFill>
+                  <a:srgbClr val="9D4E24"/>
+                </a:solidFill>
+                <a:latin typeface="Arial"/>
+                <a:ea typeface="Arial"/>
+                <a:cs typeface="Arial"/>
+              </a:rPr>
+              <a:t>9,000+</a:t>
+            </a:r>
+          </a:p>
+        </p:txBody>
+      </p:sp>
+      <p:sp>
+        <p:nvSpPr>
+          <p:cNvPr id="113" name=""/>
+          <p:cNvSpPr>
+            <a:spLocks noGrp="1"/>
+          </p:cNvSpPr>
+          <p:nvPr/>
+        </p:nvSpPr>
+        <p:spPr>
+          <a:xfrm>
+            <a:off x="3066504" y="3106420"/>
+            <a:ext cx="1684300" cy="200000"/>
+          </a:xfrm>
+          <a:prstGeom prst="rect">
+            <a:avLst/>
+          </a:prstGeom>
+          <a:noFill/>
+          <a:ln w="0">
+            <a:noFill/>
+            <a:prstDash val="solid"/>
+          </a:ln>
+        </p:spPr>
+        <p:txBody>
+          <a:bodyPr wrap="square" lIns="0" tIns="0" rIns="0" bIns="0" anchor="t">
+            <a:normAutofit fontScale="100000"/>
+          </a:bodyPr>
+          <a:lstStyle/>
+          <a:p>
+            <a:pPr algn="l">
+              <a:lnSpc>
+                <a:spcPct val="100000"/>
+              </a:lnSpc>
+              <a:buNone/>
+            </a:pPr>
+            <a:r>
+              <a:rPr sz="700" b="1" i="0">
+                <a:solidFill>
+                  <a:srgbClr val="6A6F73"/>
+                </a:solidFill>
+                <a:latin typeface="Arial"/>
+                <a:ea typeface="Arial"/>
+                <a:cs typeface="Arial"/>
+              </a:rPr>
+              <a:t>EMPLOYEES WORLDWIDE</a:t>
+            </a:r>
+          </a:p>
+        </p:txBody>
+      </p:sp>
+      <p:sp>
+        <p:nvSpPr>
+          <p:cNvPr id="114" name=""/>
+          <p:cNvSpPr>
+            <a:spLocks noGrp="1"/>
+          </p:cNvSpPr>
+          <p:nvPr/>
+        </p:nvSpPr>
+        <p:spPr>
+          <a:xfrm>
+            <a:off x="5093830" y="2560320"/>
+            <a:ext cx="2004340" cy="800100"/>
+          </a:xfrm>
+          <a:prstGeom prst="rect">
+            <a:avLst/>
+          </a:prstGeom>
+          <a:solidFill>
+            <a:srgbClr val="FFFFFF"/>
+          </a:solidFill>
+          <a:ln w="9525">
+            <a:solidFill>
+              <a:srgbClr val="D8D1C8"/>
+            </a:solidFill>
+            <a:prstDash val="solid"/>
+          </a:ln>
+        </p:spPr>
+      </p:sp>
+      <p:sp>
+        <p:nvSpPr>
+          <p:cNvPr id="115" name=""/>
+          <p:cNvSpPr>
+            <a:spLocks noGrp="1"/>
+          </p:cNvSpPr>
+          <p:nvPr/>
+        </p:nvSpPr>
+        <p:spPr>
+          <a:xfrm>
+            <a:off x="5253850" y="2683510"/>
+            <a:ext cx="1684300" cy="411480"/>
+          </a:xfrm>
+          <a:prstGeom prst="rect">
+            <a:avLst/>
+          </a:prstGeom>
+          <a:noFill/>
+          <a:ln w="0">
+            <a:noFill/>
+            <a:prstDash val="solid"/>
+          </a:ln>
+        </p:spPr>
+        <p:txBody>
+          <a:bodyPr wrap="square" lIns="0" tIns="0" rIns="0" bIns="0" anchor="t">
+            <a:normAutofit fontScale="100000"/>
+          </a:bodyPr>
+          <a:lstStyle/>
+          <a:p>
+            <a:pPr algn="l">
+              <a:lnSpc>
+                <a:spcPct val="100000"/>
+              </a:lnSpc>
+              <a:buNone/>
+            </a:pPr>
+            <a:r>
+              <a:rPr sz="1900" b="1" i="0">
+                <a:solidFill>
+                  <a:srgbClr val="9D4E24"/>
+                </a:solidFill>
+                <a:latin typeface="Arial"/>
+                <a:ea typeface="Arial"/>
+                <a:cs typeface="Arial"/>
+              </a:rPr>
+              <a:t>$9.7B</a:t>
+            </a:r>
+          </a:p>
+        </p:txBody>
+      </p:sp>
+      <p:sp>
+        <p:nvSpPr>
+          <p:cNvPr id="116" name=""/>
+          <p:cNvSpPr>
+            <a:spLocks noGrp="1"/>
+          </p:cNvSpPr>
+          <p:nvPr/>
+        </p:nvSpPr>
+        <p:spPr>
+          <a:xfrm>
+            <a:off x="5253850" y="3106420"/>
+            <a:ext cx="1684300" cy="200000"/>
+          </a:xfrm>
+          <a:prstGeom prst="rect">
+            <a:avLst/>
+          </a:prstGeom>
+          <a:noFill/>
+          <a:ln w="0">
+            <a:noFill/>
+            <a:prstDash val="solid"/>
+          </a:ln>
+        </p:spPr>
+        <p:txBody>
+          <a:bodyPr wrap="square" lIns="0" tIns="0" rIns="0" bIns="0" anchor="t">
+            <a:normAutofit fontScale="100000"/>
+          </a:bodyPr>
+          <a:lstStyle/>
+          <a:p>
+            <a:pPr algn="l">
+              <a:lnSpc>
+                <a:spcPct val="100000"/>
+              </a:lnSpc>
+              <a:buNone/>
+            </a:pPr>
+            <a:r>
+              <a:rPr sz="700" b="1" i="0">
+                <a:solidFill>
+                  <a:srgbClr val="6A6F73"/>
+                </a:solidFill>
+                <a:latin typeface="Arial"/>
+                <a:ea typeface="Arial"/>
+                <a:cs typeface="Arial"/>
+              </a:rPr>
+              <a:t>2025 REVENUE · FORBES EST.</a:t>
+            </a:r>
+          </a:p>
+        </p:txBody>
+      </p:sp>
+      <p:sp>
+        <p:nvSpPr>
+          <p:cNvPr id="117" name=""/>
+          <p:cNvSpPr>
+            <a:spLocks noGrp="1"/>
+          </p:cNvSpPr>
+          <p:nvPr/>
+        </p:nvSpPr>
+        <p:spPr>
+          <a:xfrm>
+            <a:off x="7281176" y="2560320"/>
+            <a:ext cx="2004340" cy="800100"/>
+          </a:xfrm>
+          <a:prstGeom prst="rect">
+            <a:avLst/>
+          </a:prstGeom>
+          <a:solidFill>
+            <a:srgbClr val="FFFFFF"/>
+          </a:solidFill>
+          <a:ln w="9525">
+            <a:solidFill>
+              <a:srgbClr val="D8D1C8"/>
+            </a:solidFill>
+            <a:prstDash val="solid"/>
+          </a:ln>
+        </p:spPr>
+      </p:sp>
+      <p:sp>
+        <p:nvSpPr>
+          <p:cNvPr id="118" name=""/>
+          <p:cNvSpPr>
+            <a:spLocks noGrp="1"/>
+          </p:cNvSpPr>
+          <p:nvPr/>
+        </p:nvSpPr>
+        <p:spPr>
+          <a:xfrm>
+            <a:off x="7441196" y="2683510"/>
+            <a:ext cx="1684300" cy="411480"/>
+          </a:xfrm>
+          <a:prstGeom prst="rect">
+            <a:avLst/>
+          </a:prstGeom>
+          <a:noFill/>
+          <a:ln w="0">
+            <a:noFill/>
+            <a:prstDash val="solid"/>
+          </a:ln>
+        </p:spPr>
+        <p:txBody>
+          <a:bodyPr wrap="square" lIns="0" tIns="0" rIns="0" bIns="0" anchor="t">
+            <a:normAutofit fontScale="100000"/>
+          </a:bodyPr>
+          <a:lstStyle/>
+          <a:p>
+            <a:pPr algn="l">
+              <a:lnSpc>
+                <a:spcPct val="100000"/>
+              </a:lnSpc>
+              <a:buNone/>
+            </a:pPr>
+            <a:r>
+              <a:rPr sz="1900" b="1" i="0">
+                <a:solidFill>
+                  <a:srgbClr val="9D4E24"/>
+                </a:solidFill>
+                <a:latin typeface="Arial"/>
+                <a:ea typeface="Arial"/>
+                <a:cs typeface="Arial"/>
+              </a:rPr>
+              <a:t>12</a:t>
+            </a:r>
+          </a:p>
+        </p:txBody>
+      </p:sp>
+      <p:sp>
+        <p:nvSpPr>
+          <p:cNvPr id="119" name=""/>
+          <p:cNvSpPr>
+            <a:spLocks noGrp="1"/>
+          </p:cNvSpPr>
+          <p:nvPr/>
+        </p:nvSpPr>
+        <p:spPr>
+          <a:xfrm>
+            <a:off x="7441196" y="3106420"/>
+            <a:ext cx="1684300" cy="200000"/>
+          </a:xfrm>
+          <a:prstGeom prst="rect">
+            <a:avLst/>
+          </a:prstGeom>
+          <a:noFill/>
+          <a:ln w="0">
+            <a:noFill/>
+            <a:prstDash val="solid"/>
+          </a:ln>
+        </p:spPr>
+        <p:txBody>
+          <a:bodyPr wrap="square" lIns="0" tIns="0" rIns="0" bIns="0" anchor="t">
+            <a:normAutofit fontScale="100000"/>
+          </a:bodyPr>
+          <a:lstStyle/>
+          <a:p>
+            <a:pPr algn="l">
+              <a:lnSpc>
+                <a:spcPct val="100000"/>
+              </a:lnSpc>
+              <a:buNone/>
+            </a:pPr>
+            <a:r>
+              <a:rPr sz="700" b="1" i="0">
+                <a:solidFill>
+                  <a:srgbClr val="6A6F73"/>
+                </a:solidFill>
+                <a:latin typeface="Arial"/>
+                <a:ea typeface="Arial"/>
+                <a:cs typeface="Arial"/>
+              </a:rPr>
+              <a:t>INDUSTRIES SERVED</a:t>
+            </a:r>
+          </a:p>
+        </p:txBody>
+      </p:sp>
+      <p:sp>
+        <p:nvSpPr>
+          <p:cNvPr id="120" name=""/>
+          <p:cNvSpPr>
+            <a:spLocks noGrp="1"/>
+          </p:cNvSpPr>
+          <p:nvPr/>
+        </p:nvSpPr>
+        <p:spPr>
+          <a:xfrm>
+            <a:off x="9468522" y="2560320"/>
+            <a:ext cx="2004340" cy="800100"/>
+          </a:xfrm>
+          <a:prstGeom prst="rect">
+            <a:avLst/>
+          </a:prstGeom>
+          <a:solidFill>
+            <a:srgbClr val="FFFFFF"/>
+          </a:solidFill>
+          <a:ln w="9525">
+            <a:solidFill>
+              <a:srgbClr val="D8D1C8"/>
+            </a:solidFill>
+            <a:prstDash val="solid"/>
+          </a:ln>
+        </p:spPr>
+      </p:sp>
+      <p:sp>
+        <p:nvSpPr>
+          <p:cNvPr id="121" name=""/>
+          <p:cNvSpPr>
+            <a:spLocks noGrp="1"/>
+          </p:cNvSpPr>
+          <p:nvPr/>
+        </p:nvSpPr>
+        <p:spPr>
+          <a:xfrm>
+            <a:off x="9628542" y="2683510"/>
+            <a:ext cx="1684300" cy="411480"/>
+          </a:xfrm>
+          <a:prstGeom prst="rect">
+            <a:avLst/>
+          </a:prstGeom>
+          <a:noFill/>
+          <a:ln w="0">
+            <a:noFill/>
+            <a:prstDash val="solid"/>
+          </a:ln>
+        </p:spPr>
+        <p:txBody>
+          <a:bodyPr wrap="square" lIns="0" tIns="0" rIns="0" bIns="0" anchor="t">
+            <a:normAutofit fontScale="100000"/>
+          </a:bodyPr>
+          <a:lstStyle/>
+          <a:p>
+            <a:pPr algn="l">
+              <a:lnSpc>
+                <a:spcPct val="100000"/>
+              </a:lnSpc>
+              <a:buNone/>
+            </a:pPr>
+            <a:r>
+              <a:rPr sz="1900" b="1" i="0">
+                <a:solidFill>
+                  <a:srgbClr val="9D4E24"/>
+                </a:solidFill>
+                <a:latin typeface="Arial"/>
+                <a:ea typeface="Arial"/>
+                <a:cs typeface="Arial"/>
+              </a:rPr>
+              <a:t>7</a:t>
+            </a:r>
+          </a:p>
+        </p:txBody>
+      </p:sp>
+      <p:sp>
+        <p:nvSpPr>
+          <p:cNvPr id="122" name=""/>
+          <p:cNvSpPr>
+            <a:spLocks noGrp="1"/>
+          </p:cNvSpPr>
+          <p:nvPr/>
+        </p:nvSpPr>
+        <p:spPr>
+          <a:xfrm>
+            <a:off x="9628542" y="3106420"/>
+            <a:ext cx="1684300" cy="200000"/>
+          </a:xfrm>
+          <a:prstGeom prst="rect">
+            <a:avLst/>
+          </a:prstGeom>
+          <a:noFill/>
+          <a:ln w="0">
+            <a:noFill/>
+            <a:prstDash val="solid"/>
+          </a:ln>
+        </p:spPr>
+        <p:txBody>
+          <a:bodyPr wrap="square" lIns="0" tIns="0" rIns="0" bIns="0" anchor="t">
+            <a:normAutofit fontScale="100000"/>
+          </a:bodyPr>
+          <a:lstStyle/>
+          <a:p>
+            <a:pPr algn="l">
+              <a:lnSpc>
+                <a:spcPct val="100000"/>
+              </a:lnSpc>
+              <a:buNone/>
+            </a:pPr>
+            <a:r>
+              <a:rPr sz="700" b="1" i="0">
+                <a:solidFill>
+                  <a:srgbClr val="6A6F73"/>
+                </a:solidFill>
+                <a:latin typeface="Arial"/>
+                <a:ea typeface="Arial"/>
+                <a:cs typeface="Arial"/>
+              </a:rPr>
+              <a:t>COPPER MARK SITES</a:t>
+            </a:r>
+          </a:p>
+        </p:txBody>
+      </p:sp>
+      <p:sp>
+        <p:nvSpPr>
+          <p:cNvPr id="123" name=""/>
+          <p:cNvSpPr>
+            <a:spLocks noGrp="1"/>
+          </p:cNvSpPr>
+          <p:nvPr/>
+        </p:nvSpPr>
+        <p:spPr>
+          <a:xfrm>
+            <a:off x="719138" y="3611880"/>
+            <a:ext cx="6000000" cy="228600"/>
+          </a:xfrm>
+          <a:prstGeom prst="rect">
+            <a:avLst/>
+          </a:prstGeom>
+          <a:noFill/>
+          <a:ln w="0">
+            <a:noFill/>
+            <a:prstDash val="solid"/>
+          </a:ln>
+        </p:spPr>
+        <p:txBody>
+          <a:bodyPr wrap="square" lIns="0" tIns="0" rIns="0" bIns="0" anchor="t">
+            <a:normAutofit fontScale="100000"/>
+          </a:bodyPr>
+          <a:lstStyle/>
+          <a:p>
+            <a:pPr algn="l">
+              <a:lnSpc>
+                <a:spcPct val="100000"/>
+              </a:lnSpc>
+              <a:buNone/>
+            </a:pPr>
+            <a:r>
+              <a:rPr sz="880" b="1" i="0">
+                <a:solidFill>
+                  <a:srgbClr val="9D4E24"/>
+                </a:solidFill>
+                <a:latin typeface="Arial"/>
+                <a:ea typeface="Arial"/>
+                <a:cs typeface="Arial"/>
+              </a:rPr>
+              <a:t>WHAT WE MAKE</a:t>
+            </a:r>
+          </a:p>
+        </p:txBody>
+      </p:sp>
+      <p:sp>
+        <p:nvSpPr>
+          <p:cNvPr id="124" name=""/>
+          <p:cNvSpPr>
+            <a:spLocks noGrp="1"/>
+          </p:cNvSpPr>
+          <p:nvPr/>
+        </p:nvSpPr>
+        <p:spPr>
+          <a:xfrm>
+            <a:off x="719138" y="3931920"/>
+            <a:ext cx="3300000" cy="480000"/>
+          </a:xfrm>
+          <a:prstGeom prst="rect">
+            <a:avLst/>
+          </a:prstGeom>
+          <a:noFill/>
+          <a:ln w="0">
+            <a:noFill/>
+            <a:prstDash val="solid"/>
+          </a:ln>
+        </p:spPr>
+        <p:txBody>
+          <a:bodyPr wrap="square" lIns="0" tIns="0" rIns="0" bIns="0" anchor="t">
+            <a:normAutofit fontScale="100000"/>
+          </a:bodyPr>
+          <a:lstStyle/>
+          <a:p>
+            <a:pPr algn="l">
+              <a:lnSpc>
+                <a:spcPct val="104000"/>
+              </a:lnSpc>
+              <a:buNone/>
+            </a:pPr>
+            <a:r>
+              <a:rPr sz="900" b="1" i="0">
+                <a:solidFill>
+                  <a:srgbClr val="17191C"/>
+                </a:solidFill>
+                <a:latin typeface="Arial"/>
+                <a:ea typeface="Arial"/>
+                <a:cs typeface="Arial"/>
+              </a:rPr>
+              <a:t>High voltage underground</a:t>
+            </a:r>
+            <a:r>
+              <a:rPr sz="900" b="0" i="0">
+                <a:solidFill>
+                  <a:srgbClr val="6A6F73"/>
+                </a:solidFill>
+                <a:latin typeface="Arial"/>
+                <a:ea typeface="Arial"/>
+                <a:cs typeface="Arial"/>
+              </a:rPr>
+              <a:t> — 69–500 kV cable, accessories, installation engineering and field testing.</a:t>
+            </a:r>
+          </a:p>
+        </p:txBody>
+      </p:sp>
+      <p:sp>
+        <p:nvSpPr>
+          <p:cNvPr id="125" name=""/>
+          <p:cNvSpPr>
+            <a:spLocks noGrp="1"/>
+          </p:cNvSpPr>
+          <p:nvPr/>
+        </p:nvSpPr>
+        <p:spPr>
+          <a:xfrm>
+            <a:off x="4219138" y="3931920"/>
+            <a:ext cx="3300000" cy="480000"/>
+          </a:xfrm>
+          <a:prstGeom prst="rect">
+            <a:avLst/>
+          </a:prstGeom>
+          <a:noFill/>
+          <a:ln w="0">
+            <a:noFill/>
+            <a:prstDash val="solid"/>
+          </a:ln>
+        </p:spPr>
+        <p:txBody>
+          <a:bodyPr wrap="square" lIns="0" tIns="0" rIns="0" bIns="0" anchor="t">
+            <a:normAutofit fontScale="100000"/>
+          </a:bodyPr>
+          <a:lstStyle/>
+          <a:p>
+            <a:pPr algn="l">
+              <a:lnSpc>
+                <a:spcPct val="104000"/>
+              </a:lnSpc>
+              <a:buNone/>
+            </a:pPr>
+            <a:r>
+              <a:rPr sz="900" b="1" i="0">
+                <a:solidFill>
+                  <a:srgbClr val="17191C"/>
+                </a:solidFill>
+                <a:latin typeface="Arial"/>
+                <a:ea typeface="Arial"/>
+                <a:cs typeface="Arial"/>
+              </a:rPr>
+              <a:t>Medium &amp; low voltage</a:t>
+            </a:r>
+            <a:r>
+              <a:rPr sz="900" b="0" i="0">
+                <a:solidFill>
+                  <a:srgbClr val="6A6F73"/>
+                </a:solidFill>
+                <a:latin typeface="Arial"/>
+                <a:ea typeface="Arial"/>
+                <a:cs typeface="Arial"/>
+              </a:rPr>
+              <a:t> — 5–35 kV EPR/XLPE; 600 V power and control; tray-rated TC-ER.</a:t>
+            </a:r>
+          </a:p>
+        </p:txBody>
+      </p:sp>
+      <p:sp>
+        <p:nvSpPr>
+          <p:cNvPr id="126" name=""/>
+          <p:cNvSpPr>
+            <a:spLocks noGrp="1"/>
+          </p:cNvSpPr>
+          <p:nvPr/>
+        </p:nvSpPr>
+        <p:spPr>
+          <a:xfrm>
+            <a:off x="719138" y="4434840"/>
+            <a:ext cx="3300000" cy="480000"/>
+          </a:xfrm>
+          <a:prstGeom prst="rect">
+            <a:avLst/>
+          </a:prstGeom>
+          <a:noFill/>
+          <a:ln w="0">
+            <a:noFill/>
+            <a:prstDash val="solid"/>
+          </a:ln>
+        </p:spPr>
+        <p:txBody>
+          <a:bodyPr wrap="square" lIns="0" tIns="0" rIns="0" bIns="0" anchor="t">
+            <a:normAutofit fontScale="100000"/>
+          </a:bodyPr>
+          <a:lstStyle/>
+          <a:p>
+            <a:pPr algn="l">
+              <a:lnSpc>
+                <a:spcPct val="104000"/>
+              </a:lnSpc>
+              <a:buNone/>
+            </a:pPr>
+            <a:r>
+              <a:rPr sz="900" b="1" i="0">
+                <a:solidFill>
+                  <a:srgbClr val="17191C"/>
+                </a:solidFill>
+                <a:latin typeface="Arial"/>
+                <a:ea typeface="Arial"/>
+                <a:cs typeface="Arial"/>
+              </a:rPr>
+              <a:t>Instrumentation &amp; comms</a:t>
+            </a:r>
+            <a:r>
+              <a:rPr sz="900" b="0" i="0">
+                <a:solidFill>
+                  <a:srgbClr val="6A6F73"/>
+                </a:solidFill>
+                <a:latin typeface="Arial"/>
+                <a:ea typeface="Arial"/>
+                <a:cs typeface="Arial"/>
+              </a:rPr>
+              <a:t> — shielded pairs and triads, thermocouple, industrial Ethernet and fiber.</a:t>
+            </a:r>
+          </a:p>
+        </p:txBody>
+      </p:sp>
+      <p:sp>
+        <p:nvSpPr>
+          <p:cNvPr id="127" name=""/>
+          <p:cNvSpPr>
+            <a:spLocks noGrp="1"/>
+          </p:cNvSpPr>
+          <p:nvPr/>
+        </p:nvSpPr>
+        <p:spPr>
+          <a:xfrm>
+            <a:off x="4219138" y="4434840"/>
+            <a:ext cx="3300000" cy="480000"/>
+          </a:xfrm>
+          <a:prstGeom prst="rect">
+            <a:avLst/>
+          </a:prstGeom>
+          <a:noFill/>
+          <a:ln w="0">
+            <a:noFill/>
+            <a:prstDash val="solid"/>
+          </a:ln>
+        </p:spPr>
+        <p:txBody>
+          <a:bodyPr wrap="square" lIns="0" tIns="0" rIns="0" bIns="0" anchor="t">
+            <a:normAutofit fontScale="100000"/>
+          </a:bodyPr>
+          <a:lstStyle/>
+          <a:p>
+            <a:pPr algn="l">
+              <a:lnSpc>
+                <a:spcPct val="104000"/>
+              </a:lnSpc>
+              <a:buNone/>
+            </a:pPr>
+            <a:r>
+              <a:rPr sz="900" b="1" i="0">
+                <a:solidFill>
+                  <a:srgbClr val="17191C"/>
+                </a:solidFill>
+                <a:latin typeface="Arial"/>
+                <a:ea typeface="Arial"/>
+                <a:cs typeface="Arial"/>
+              </a:rPr>
+              <a:t>Overhead conductors</a:t>
+            </a:r>
+            <a:r>
+              <a:rPr sz="900" b="0" i="0">
+                <a:solidFill>
+                  <a:srgbClr val="6A6F73"/>
+                </a:solidFill>
+                <a:latin typeface="Arial"/>
+                <a:ea typeface="Arial"/>
+                <a:cs typeface="Arial"/>
+              </a:rPr>
+              <a:t> — C7 composite-core, ACSS/TW, vibration-resistant, high-emissivity.</a:t>
+            </a:r>
+          </a:p>
+        </p:txBody>
+      </p:sp>
+      <p:sp>
+        <p:nvSpPr>
+          <p:cNvPr id="128" name=""/>
+          <p:cNvSpPr>
+            <a:spLocks noGrp="1"/>
+          </p:cNvSpPr>
+          <p:nvPr/>
+        </p:nvSpPr>
+        <p:spPr>
+          <a:xfrm>
+            <a:off x="719138" y="4937760"/>
+            <a:ext cx="3300000" cy="480000"/>
+          </a:xfrm>
+          <a:prstGeom prst="rect">
+            <a:avLst/>
+          </a:prstGeom>
+          <a:noFill/>
+          <a:ln w="0">
+            <a:noFill/>
+            <a:prstDash val="solid"/>
+          </a:ln>
+        </p:spPr>
+        <p:txBody>
+          <a:bodyPr wrap="square" lIns="0" tIns="0" rIns="0" bIns="0" anchor="t">
+            <a:normAutofit fontScale="100000"/>
+          </a:bodyPr>
+          <a:lstStyle/>
+          <a:p>
+            <a:pPr algn="l">
+              <a:lnSpc>
+                <a:spcPct val="104000"/>
+              </a:lnSpc>
+              <a:buNone/>
+            </a:pPr>
+            <a:r>
+              <a:rPr sz="900" b="1" i="0">
+                <a:solidFill>
+                  <a:srgbClr val="17191C"/>
+                </a:solidFill>
+                <a:latin typeface="Arial"/>
+                <a:ea typeface="Arial"/>
+                <a:cs typeface="Arial"/>
+              </a:rPr>
+              <a:t>Classified &amp; circuit integrity</a:t>
+            </a:r>
+            <a:r>
+              <a:rPr sz="900" b="0" i="0">
+                <a:solidFill>
+                  <a:srgbClr val="6A6F73"/>
+                </a:solidFill>
+                <a:latin typeface="Arial"/>
+                <a:ea typeface="Arial"/>
+                <a:cs typeface="Arial"/>
+              </a:rPr>
+              <a:t> — MC-HL, two-hour-rated cable and splice kits.</a:t>
+            </a:r>
+          </a:p>
+        </p:txBody>
+      </p:sp>
+      <p:sp>
+        <p:nvSpPr>
+          <p:cNvPr id="129" name=""/>
+          <p:cNvSpPr>
+            <a:spLocks noGrp="1"/>
+          </p:cNvSpPr>
+          <p:nvPr/>
+        </p:nvSpPr>
+        <p:spPr>
+          <a:xfrm>
+            <a:off x="4219138" y="4937760"/>
+            <a:ext cx="3300000" cy="480000"/>
+          </a:xfrm>
+          <a:prstGeom prst="rect">
+            <a:avLst/>
+          </a:prstGeom>
+          <a:noFill/>
+          <a:ln w="0">
+            <a:noFill/>
+            <a:prstDash val="solid"/>
+          </a:ln>
+        </p:spPr>
+        <p:txBody>
+          <a:bodyPr wrap="square" lIns="0" tIns="0" rIns="0" bIns="0" anchor="t">
+            <a:normAutofit fontScale="100000"/>
+          </a:bodyPr>
+          <a:lstStyle/>
+          <a:p>
+            <a:pPr algn="l">
+              <a:lnSpc>
+                <a:spcPct val="104000"/>
+              </a:lnSpc>
+              <a:buNone/>
+            </a:pPr>
+            <a:r>
+              <a:rPr sz="900" b="1" i="0">
+                <a:solidFill>
+                  <a:srgbClr val="17191C"/>
+                </a:solidFill>
+                <a:latin typeface="Arial"/>
+                <a:ea typeface="Arial"/>
+                <a:cs typeface="Arial"/>
+              </a:rPr>
+              <a:t>Modular &amp; factory-built power</a:t>
+            </a:r>
+            <a:r>
+              <a:rPr sz="900" b="0" i="0">
+                <a:solidFill>
+                  <a:srgbClr val="6A6F73"/>
+                </a:solidFill>
+                <a:latin typeface="Arial"/>
+                <a:ea typeface="Arial"/>
+                <a:cs typeface="Arial"/>
+              </a:rPr>
+              <a:t> — fine-strand flexible, VFD and tray cable; whips and job kits.</a:t>
+            </a:r>
+          </a:p>
+        </p:txBody>
+      </p:sp>
+      <p:sp>
+        <p:nvSpPr>
+          <p:cNvPr id="130" name=""/>
+          <p:cNvSpPr>
+            <a:spLocks noGrp="1"/>
+          </p:cNvSpPr>
+          <p:nvPr/>
+        </p:nvSpPr>
+        <p:spPr>
+          <a:xfrm>
+            <a:off x="719138" y="5440680"/>
+            <a:ext cx="3300000" cy="480000"/>
+          </a:xfrm>
+          <a:prstGeom prst="rect">
+            <a:avLst/>
+          </a:prstGeom>
+          <a:noFill/>
+          <a:ln w="0">
+            <a:noFill/>
+            <a:prstDash val="solid"/>
+          </a:ln>
+        </p:spPr>
+        <p:txBody>
+          <a:bodyPr wrap="square" lIns="0" tIns="0" rIns="0" bIns="0" anchor="t">
+            <a:normAutofit fontScale="100000"/>
+          </a:bodyPr>
+          <a:lstStyle/>
+          <a:p>
+            <a:pPr algn="l">
+              <a:lnSpc>
+                <a:spcPct val="104000"/>
+              </a:lnSpc>
+              <a:buNone/>
+            </a:pPr>
+            <a:r>
+              <a:rPr sz="900" b="1" i="0">
+                <a:solidFill>
+                  <a:srgbClr val="17191C"/>
+                </a:solidFill>
+                <a:latin typeface="Arial"/>
+                <a:ea typeface="Arial"/>
+                <a:cs typeface="Arial"/>
+              </a:rPr>
+              <a:t>Data center assemblies</a:t>
+            </a:r>
+            <a:r>
+              <a:rPr sz="900" b="0" i="0">
+                <a:solidFill>
+                  <a:srgbClr val="6A6F73"/>
+                </a:solidFill>
+                <a:latin typeface="Arial"/>
+                <a:ea typeface="Arial"/>
+                <a:cs typeface="Arial"/>
+              </a:rPr>
+              <a:t> — UL-listed, built, labeled, tested, drum-packed to schedule.</a:t>
+            </a:r>
+          </a:p>
+        </p:txBody>
+      </p:sp>
+      <p:sp>
+        <p:nvSpPr>
+          <p:cNvPr id="131" name=""/>
+          <p:cNvSpPr>
+            <a:spLocks noGrp="1"/>
+          </p:cNvSpPr>
+          <p:nvPr/>
+        </p:nvSpPr>
+        <p:spPr>
+          <a:xfrm>
+            <a:off x="4219138" y="5440680"/>
+            <a:ext cx="3300000" cy="480000"/>
+          </a:xfrm>
+          <a:prstGeom prst="rect">
+            <a:avLst/>
+          </a:prstGeom>
+          <a:noFill/>
+          <a:ln w="0">
+            <a:noFill/>
+            <a:prstDash val="solid"/>
+          </a:ln>
+        </p:spPr>
+        <p:txBody>
+          <a:bodyPr wrap="square" lIns="0" tIns="0" rIns="0" bIns="0" anchor="t">
+            <a:normAutofit fontScale="100000"/>
+          </a:bodyPr>
+          <a:lstStyle/>
+          <a:p>
+            <a:pPr algn="l">
+              <a:lnSpc>
+                <a:spcPct val="104000"/>
+              </a:lnSpc>
+              <a:buNone/>
+            </a:pPr>
+            <a:r>
+              <a:rPr sz="900" b="1" i="0">
+                <a:solidFill>
+                  <a:srgbClr val="17191C"/>
+                </a:solidFill>
+                <a:latin typeface="Arial"/>
+                <a:ea typeface="Arial"/>
+                <a:cs typeface="Arial"/>
+              </a:rPr>
+              <a:t>Accessories &amp; raceway</a:t>
+            </a:r>
+            <a:r>
+              <a:rPr sz="900" b="0" i="0">
+                <a:solidFill>
+                  <a:srgbClr val="6A6F73"/>
+                </a:solidFill>
+                <a:latin typeface="Arial"/>
+                <a:ea typeface="Arial"/>
+                <a:cs typeface="Arial"/>
+              </a:rPr>
+              <a:t> — lugs, grounding, duct-bank accessories and pulling gear.</a:t>
+            </a:r>
+          </a:p>
+        </p:txBody>
+      </p:sp>
+      <p:sp>
+        <p:nvSpPr>
+          <p:cNvPr id="132" name=""/>
+          <p:cNvSpPr>
+            <a:spLocks noGrp="1"/>
+          </p:cNvSpPr>
+          <p:nvPr/>
+        </p:nvSpPr>
+        <p:spPr>
+          <a:xfrm>
+            <a:off x="8000000" y="3611880"/>
+            <a:ext cx="3472862" cy="228600"/>
+          </a:xfrm>
+          <a:prstGeom prst="rect">
+            <a:avLst/>
+          </a:prstGeom>
+          <a:noFill/>
+          <a:ln w="0">
+            <a:noFill/>
+            <a:prstDash val="solid"/>
+          </a:ln>
+        </p:spPr>
+        <p:txBody>
+          <a:bodyPr wrap="square" lIns="0" tIns="0" rIns="0" bIns="0" anchor="t">
+            <a:normAutofit fontScale="100000"/>
+          </a:bodyPr>
+          <a:lstStyle/>
+          <a:p>
+            <a:pPr algn="l">
+              <a:lnSpc>
+                <a:spcPct val="100000"/>
+              </a:lnSpc>
+              <a:buNone/>
+            </a:pPr>
+            <a:r>
+              <a:rPr sz="880" b="1" i="0">
+                <a:solidFill>
+                  <a:srgbClr val="9D4E24"/>
+                </a:solidFill>
+                <a:latin typeface="Arial"/>
+                <a:ea typeface="Arial"/>
+                <a:cs typeface="Arial"/>
+              </a:rPr>
+              <a:t>WHAT WE DO</a:t>
+            </a:r>
+          </a:p>
+        </p:txBody>
+      </p:sp>
+      <p:sp>
+        <p:nvSpPr>
+          <p:cNvPr id="133" name=""/>
+          <p:cNvSpPr>
+            <a:spLocks noGrp="1"/>
+          </p:cNvSpPr>
+          <p:nvPr/>
+        </p:nvSpPr>
+        <p:spPr>
+          <a:xfrm>
+            <a:off x="8000000" y="3931920"/>
+            <a:ext cx="1700000" cy="270000"/>
+          </a:xfrm>
+          <a:prstGeom prst="rect">
+            <a:avLst/>
+          </a:prstGeom>
+          <a:noFill/>
+          <a:ln w="0">
+            <a:noFill/>
+            <a:prstDash val="solid"/>
+          </a:ln>
+        </p:spPr>
+        <p:txBody>
+          <a:bodyPr wrap="square" lIns="0" tIns="0" rIns="0" bIns="0" anchor="t">
+            <a:normAutofit fontScale="100000"/>
+          </a:bodyPr>
+          <a:lstStyle/>
+          <a:p>
+            <a:pPr algn="l">
+              <a:lnSpc>
+                <a:spcPct val="100000"/>
+              </a:lnSpc>
+              <a:buNone/>
+            </a:pPr>
+            <a:r>
+              <a:rPr sz="800" b="0" i="0">
+                <a:solidFill>
+                  <a:srgbClr val="6A6F73"/>
+                </a:solidFill>
+                <a:latin typeface="Arial"/>
+                <a:ea typeface="Arial"/>
+                <a:cs typeface="Arial"/>
+              </a:rPr>
+              <a:t>HV underground transmission</a:t>
+            </a:r>
+          </a:p>
+        </p:txBody>
+      </p:sp>
+      <p:sp>
+        <p:nvSpPr>
+          <p:cNvPr id="134" name=""/>
+          <p:cNvSpPr>
+            <a:spLocks noGrp="1"/>
+          </p:cNvSpPr>
+          <p:nvPr/>
+        </p:nvSpPr>
+        <p:spPr>
+          <a:xfrm>
+            <a:off x="9790000" y="3931920"/>
+            <a:ext cx="1700000" cy="270000"/>
+          </a:xfrm>
+          <a:prstGeom prst="rect">
+            <a:avLst/>
+          </a:prstGeom>
+          <a:noFill/>
+          <a:ln w="0">
+            <a:noFill/>
+            <a:prstDash val="solid"/>
+          </a:ln>
+        </p:spPr>
+        <p:txBody>
+          <a:bodyPr wrap="square" lIns="0" tIns="0" rIns="0" bIns="0" anchor="t">
+            <a:normAutofit fontScale="100000"/>
+          </a:bodyPr>
+          <a:lstStyle/>
+          <a:p>
+            <a:pPr algn="l">
+              <a:lnSpc>
+                <a:spcPct val="100000"/>
+              </a:lnSpc>
+              <a:buNone/>
+            </a:pPr>
+            <a:r>
+              <a:rPr sz="800" b="0" i="0">
+                <a:solidFill>
+                  <a:srgbClr val="6A6F73"/>
+                </a:solidFill>
+                <a:latin typeface="Arial"/>
+                <a:ea typeface="Arial"/>
+                <a:cs typeface="Arial"/>
+              </a:rPr>
+              <a:t>Cable rejuvenation</a:t>
+            </a:r>
+          </a:p>
+        </p:txBody>
+      </p:sp>
+      <p:sp>
+        <p:nvSpPr>
+          <p:cNvPr id="135" name=""/>
+          <p:cNvSpPr>
+            <a:spLocks noGrp="1"/>
+          </p:cNvSpPr>
+          <p:nvPr/>
+        </p:nvSpPr>
+        <p:spPr>
+          <a:xfrm>
+            <a:off x="8000000" y="4221920"/>
+            <a:ext cx="1700000" cy="270000"/>
+          </a:xfrm>
+          <a:prstGeom prst="rect">
+            <a:avLst/>
+          </a:prstGeom>
+          <a:noFill/>
+          <a:ln w="0">
+            <a:noFill/>
+            <a:prstDash val="solid"/>
+          </a:ln>
+        </p:spPr>
+        <p:txBody>
+          <a:bodyPr wrap="square" lIns="0" tIns="0" rIns="0" bIns="0" anchor="t">
+            <a:normAutofit fontScale="100000"/>
+          </a:bodyPr>
+          <a:lstStyle/>
+          <a:p>
+            <a:pPr algn="l">
+              <a:lnSpc>
+                <a:spcPct val="100000"/>
+              </a:lnSpc>
+              <a:buNone/>
+            </a:pPr>
+            <a:r>
+              <a:rPr sz="800" b="0" i="0">
+                <a:solidFill>
+                  <a:srgbClr val="6A6F73"/>
+                </a:solidFill>
+                <a:latin typeface="Arial"/>
+                <a:ea typeface="Arial"/>
+                <a:cs typeface="Arial"/>
+              </a:rPr>
+              <a:t>Contractor solutions</a:t>
+            </a:r>
+          </a:p>
+        </p:txBody>
+      </p:sp>
+      <p:sp>
+        <p:nvSpPr>
+          <p:cNvPr id="136" name=""/>
+          <p:cNvSpPr>
+            <a:spLocks noGrp="1"/>
+          </p:cNvSpPr>
+          <p:nvPr/>
+        </p:nvSpPr>
+        <p:spPr>
+          <a:xfrm>
+            <a:off x="9790000" y="4221920"/>
+            <a:ext cx="1700000" cy="270000"/>
+          </a:xfrm>
+          <a:prstGeom prst="rect">
+            <a:avLst/>
+          </a:prstGeom>
+          <a:noFill/>
+          <a:ln w="0">
+            <a:noFill/>
+            <a:prstDash val="solid"/>
+          </a:ln>
+        </p:spPr>
+        <p:txBody>
+          <a:bodyPr wrap="square" lIns="0" tIns="0" rIns="0" bIns="0" anchor="t">
+            <a:normAutofit fontScale="100000"/>
+          </a:bodyPr>
+          <a:lstStyle/>
+          <a:p>
+            <a:pPr algn="l">
+              <a:lnSpc>
+                <a:spcPct val="100000"/>
+              </a:lnSpc>
+              <a:buNone/>
+            </a:pPr>
+            <a:r>
+              <a:rPr sz="800" b="0" i="0">
+                <a:solidFill>
+                  <a:srgbClr val="6A6F73"/>
+                </a:solidFill>
+                <a:latin typeface="Arial"/>
+                <a:ea typeface="Arial"/>
+                <a:cs typeface="Arial"/>
+              </a:rPr>
+              <a:t>Speed to Power services</a:t>
+            </a:r>
+          </a:p>
+        </p:txBody>
+      </p:sp>
+      <p:sp>
+        <p:nvSpPr>
+          <p:cNvPr id="137" name=""/>
+          <p:cNvSpPr>
+            <a:spLocks noGrp="1"/>
+          </p:cNvSpPr>
+          <p:nvPr/>
+        </p:nvSpPr>
+        <p:spPr>
+          <a:xfrm>
+            <a:off x="8000000" y="4511920"/>
+            <a:ext cx="1700000" cy="270000"/>
+          </a:xfrm>
+          <a:prstGeom prst="rect">
+            <a:avLst/>
+          </a:prstGeom>
+          <a:noFill/>
+          <a:ln w="0">
+            <a:noFill/>
+            <a:prstDash val="solid"/>
+          </a:ln>
+        </p:spPr>
+        <p:txBody>
+          <a:bodyPr wrap="square" lIns="0" tIns="0" rIns="0" bIns="0" anchor="t">
+            <a:normAutofit fontScale="100000"/>
+          </a:bodyPr>
+          <a:lstStyle/>
+          <a:p>
+            <a:pPr algn="l">
+              <a:lnSpc>
+                <a:spcPct val="100000"/>
+              </a:lnSpc>
+              <a:buNone/>
+            </a:pPr>
+            <a:r>
+              <a:rPr sz="800" b="0" i="0">
+                <a:solidFill>
+                  <a:srgbClr val="6A6F73"/>
+                </a:solidFill>
+                <a:latin typeface="Arial"/>
+                <a:ea typeface="Arial"/>
+                <a:cs typeface="Arial"/>
+              </a:rPr>
+              <a:t>Project services</a:t>
+            </a:r>
+          </a:p>
+        </p:txBody>
+      </p:sp>
+      <p:sp>
+        <p:nvSpPr>
+          <p:cNvPr id="138" name=""/>
+          <p:cNvSpPr>
+            <a:spLocks noGrp="1"/>
+          </p:cNvSpPr>
+          <p:nvPr/>
+        </p:nvSpPr>
+        <p:spPr>
+          <a:xfrm>
+            <a:off x="9790000" y="4511920"/>
+            <a:ext cx="1700000" cy="270000"/>
+          </a:xfrm>
+          <a:prstGeom prst="rect">
+            <a:avLst/>
+          </a:prstGeom>
+          <a:noFill/>
+          <a:ln w="0">
+            <a:noFill/>
+            <a:prstDash val="solid"/>
+          </a:ln>
+        </p:spPr>
+        <p:txBody>
+          <a:bodyPr wrap="square" lIns="0" tIns="0" rIns="0" bIns="0" anchor="t">
+            <a:normAutofit fontScale="100000"/>
+          </a:bodyPr>
+          <a:lstStyle/>
+          <a:p>
+            <a:pPr algn="l">
+              <a:lnSpc>
+                <a:spcPct val="100000"/>
+              </a:lnSpc>
+              <a:buNone/>
+            </a:pPr>
+            <a:r>
+              <a:rPr sz="800" b="0" i="0">
+                <a:solidFill>
+                  <a:srgbClr val="6A6F73"/>
+                </a:solidFill>
+                <a:latin typeface="Arial"/>
+                <a:ea typeface="Arial"/>
+                <a:cs typeface="Arial"/>
+              </a:rPr>
+              <a:t>Storm activation team</a:t>
+            </a:r>
+          </a:p>
+        </p:txBody>
+      </p:sp>
+      <p:sp>
+        <p:nvSpPr>
+          <p:cNvPr id="139" name=""/>
+          <p:cNvSpPr>
+            <a:spLocks noGrp="1"/>
+          </p:cNvSpPr>
+          <p:nvPr/>
+        </p:nvSpPr>
+        <p:spPr>
+          <a:xfrm>
+            <a:off x="8000000" y="4801920"/>
+            <a:ext cx="1700000" cy="270000"/>
+          </a:xfrm>
+          <a:prstGeom prst="rect">
+            <a:avLst/>
+          </a:prstGeom>
+          <a:noFill/>
+          <a:ln w="0">
+            <a:noFill/>
+            <a:prstDash val="solid"/>
+          </a:ln>
+        </p:spPr>
+        <p:txBody>
+          <a:bodyPr wrap="square" lIns="0" tIns="0" rIns="0" bIns="0" anchor="t">
+            <a:normAutofit fontScale="100000"/>
+          </a:bodyPr>
+          <a:lstStyle/>
+          <a:p>
+            <a:pPr algn="l">
+              <a:lnSpc>
+                <a:spcPct val="100000"/>
+              </a:lnSpc>
+              <a:buNone/>
+            </a:pPr>
+            <a:r>
+              <a:rPr sz="800" b="0" i="0">
+                <a:solidFill>
+                  <a:srgbClr val="6A6F73"/>
+                </a:solidFill>
+                <a:latin typeface="Arial"/>
+                <a:ea typeface="Arial"/>
+                <a:cs typeface="Arial"/>
+              </a:rPr>
+              <a:t>Field assessment services</a:t>
+            </a:r>
+          </a:p>
+        </p:txBody>
+      </p:sp>
+      <p:sp>
+        <p:nvSpPr>
+          <p:cNvPr id="140" name=""/>
+          <p:cNvSpPr>
+            <a:spLocks noGrp="1"/>
+          </p:cNvSpPr>
+          <p:nvPr/>
+        </p:nvSpPr>
+        <p:spPr>
+          <a:xfrm>
+            <a:off x="9790000" y="4801920"/>
+            <a:ext cx="1700000" cy="270000"/>
+          </a:xfrm>
+          <a:prstGeom prst="rect">
+            <a:avLst/>
+          </a:prstGeom>
+          <a:noFill/>
+          <a:ln w="0">
+            <a:noFill/>
+            <a:prstDash val="solid"/>
+          </a:ln>
+        </p:spPr>
+        <p:txBody>
+          <a:bodyPr wrap="square" lIns="0" tIns="0" rIns="0" bIns="0" anchor="t">
+            <a:normAutofit fontScale="100000"/>
+          </a:bodyPr>
+          <a:lstStyle/>
+          <a:p>
+            <a:pPr algn="l">
+              <a:lnSpc>
+                <a:spcPct val="100000"/>
+              </a:lnSpc>
+              <a:buNone/>
+            </a:pPr>
+            <a:r>
+              <a:rPr sz="800" b="0" i="0">
+                <a:solidFill>
+                  <a:srgbClr val="6A6F73"/>
+                </a:solidFill>
+                <a:latin typeface="Arial"/>
+                <a:ea typeface="Arial"/>
+                <a:cs typeface="Arial"/>
+              </a:rPr>
+              <a:t>Reel tracking system</a:t>
+            </a:r>
+          </a:p>
+        </p:txBody>
+      </p:sp>
+      <p:sp>
+        <p:nvSpPr>
+          <p:cNvPr id="141" name=""/>
+          <p:cNvSpPr>
+            <a:spLocks noGrp="1"/>
+          </p:cNvSpPr>
+          <p:nvPr/>
+        </p:nvSpPr>
+        <p:spPr>
+          <a:xfrm>
+            <a:off x="8000000" y="5091920"/>
+            <a:ext cx="1700000" cy="270000"/>
+          </a:xfrm>
+          <a:prstGeom prst="rect">
+            <a:avLst/>
+          </a:prstGeom>
+          <a:noFill/>
+          <a:ln w="0">
+            <a:noFill/>
+            <a:prstDash val="solid"/>
+          </a:ln>
+        </p:spPr>
+        <p:txBody>
+          <a:bodyPr wrap="square" lIns="0" tIns="0" rIns="0" bIns="0" anchor="t">
+            <a:normAutofit fontScale="100000"/>
+          </a:bodyPr>
+          <a:lstStyle/>
+          <a:p>
+            <a:pPr algn="l">
+              <a:lnSpc>
+                <a:spcPct val="100000"/>
+              </a:lnSpc>
+              <a:buNone/>
+            </a:pPr>
+            <a:r>
+              <a:rPr sz="800" b="0" i="0">
+                <a:solidFill>
+                  <a:srgbClr val="6A6F73"/>
+                </a:solidFill>
+                <a:latin typeface="Arial"/>
+                <a:ea typeface="Arial"/>
+                <a:cs typeface="Arial"/>
+              </a:rPr>
+              <a:t>CableTechSupport™</a:t>
+            </a:r>
+          </a:p>
+        </p:txBody>
+      </p:sp>
+      <p:sp>
+        <p:nvSpPr>
+          <p:cNvPr id="142" name=""/>
+          <p:cNvSpPr>
+            <a:spLocks noGrp="1"/>
+          </p:cNvSpPr>
+          <p:nvPr/>
+        </p:nvSpPr>
+        <p:spPr>
+          <a:xfrm>
+            <a:off x="9790000" y="5091920"/>
+            <a:ext cx="1700000" cy="270000"/>
+          </a:xfrm>
+          <a:prstGeom prst="rect">
+            <a:avLst/>
+          </a:prstGeom>
+          <a:noFill/>
+          <a:ln w="0">
+            <a:noFill/>
+            <a:prstDash val="solid"/>
+          </a:ln>
+        </p:spPr>
+        <p:txBody>
+          <a:bodyPr wrap="square" lIns="0" tIns="0" rIns="0" bIns="0" anchor="t">
+            <a:normAutofit fontScale="100000"/>
+          </a:bodyPr>
+          <a:lstStyle/>
+          <a:p>
+            <a:pPr algn="l">
+              <a:lnSpc>
+                <a:spcPct val="100000"/>
+              </a:lnSpc>
+              <a:buNone/>
+            </a:pPr>
+            <a:r>
+              <a:rPr sz="800" b="0" i="0">
+                <a:solidFill>
+                  <a:srgbClr val="6A6F73"/>
+                </a:solidFill>
+                <a:latin typeface="Arial"/>
+                <a:ea typeface="Arial"/>
+                <a:cs typeface="Arial"/>
+              </a:rPr>
+              <a:t>Solutions University</a:t>
+            </a:r>
+          </a:p>
+        </p:txBody>
+      </p:sp>
+      <p:sp>
+        <p:nvSpPr>
+          <p:cNvPr id="143" name=""/>
+          <p:cNvSpPr>
+            <a:spLocks noGrp="1"/>
+          </p:cNvSpPr>
+          <p:nvPr/>
+        </p:nvSpPr>
+        <p:spPr>
+          <a:xfrm>
+            <a:off x="8000000" y="5381920"/>
+            <a:ext cx="1700000" cy="270000"/>
+          </a:xfrm>
+          <a:prstGeom prst="rect">
+            <a:avLst/>
+          </a:prstGeom>
+          <a:noFill/>
+          <a:ln w="0">
+            <a:noFill/>
+            <a:prstDash val="solid"/>
+          </a:ln>
+        </p:spPr>
+        <p:txBody>
+          <a:bodyPr wrap="square" lIns="0" tIns="0" rIns="0" bIns="0" anchor="t">
+            <a:normAutofit fontScale="100000"/>
+          </a:bodyPr>
+          <a:lstStyle/>
+          <a:p>
+            <a:pPr algn="l">
+              <a:lnSpc>
+                <a:spcPct val="100000"/>
+              </a:lnSpc>
+              <a:buNone/>
+            </a:pPr>
+            <a:r>
+              <a:rPr sz="800" b="0" i="0">
+                <a:solidFill>
+                  <a:srgbClr val="6A6F73"/>
+                </a:solidFill>
+                <a:latin typeface="Arial"/>
+                <a:ea typeface="Arial"/>
+                <a:cs typeface="Arial"/>
+              </a:rPr>
+              <a:t>Utility services</a:t>
+            </a:r>
+          </a:p>
+        </p:txBody>
+      </p:sp>
+      <p:sp>
+        <p:nvSpPr>
+          <p:cNvPr id="144" name=""/>
+          <p:cNvSpPr>
+            <a:spLocks noGrp="1"/>
+          </p:cNvSpPr>
+          <p:nvPr/>
+        </p:nvSpPr>
+        <p:spPr>
+          <a:xfrm>
+            <a:off x="9790000" y="5381920"/>
+            <a:ext cx="1700000" cy="270000"/>
+          </a:xfrm>
+          <a:prstGeom prst="rect">
+            <a:avLst/>
+          </a:prstGeom>
+          <a:noFill/>
+          <a:ln w="0">
+            <a:noFill/>
+            <a:prstDash val="solid"/>
+          </a:ln>
+        </p:spPr>
+        <p:txBody>
+          <a:bodyPr wrap="square" lIns="0" tIns="0" rIns="0" bIns="0" anchor="t">
+            <a:normAutofit fontScale="100000"/>
+          </a:bodyPr>
+          <a:lstStyle/>
+          <a:p>
+            <a:pPr algn="l">
+              <a:lnSpc>
+                <a:spcPct val="100000"/>
+              </a:lnSpc>
+              <a:buNone/>
+            </a:pPr>
+            <a:r>
+              <a:rPr sz="800" b="0" i="0">
+                <a:solidFill>
+                  <a:srgbClr val="6A6F73"/>
+                </a:solidFill>
+                <a:latin typeface="Arial"/>
+                <a:ea typeface="Arial"/>
+                <a:cs typeface="Arial"/>
+              </a:rPr>
+              <a:t>Grid resiliency assessments</a:t>
+            </a:r>
+          </a:p>
+        </p:txBody>
+      </p:sp>
+      <p:sp>
+        <p:nvSpPr>
+          <p:cNvPr id="145" name=""/>
+          <p:cNvSpPr>
+            <a:spLocks noGrp="1"/>
+          </p:cNvSpPr>
+          <p:nvPr/>
+        </p:nvSpPr>
+        <p:spPr>
+          <a:xfrm>
+            <a:off x="719138" y="5980000"/>
+            <a:ext cx="10753724" cy="240000"/>
+          </a:xfrm>
+          <a:prstGeom prst="rect">
+            <a:avLst/>
+          </a:prstGeom>
+          <a:noFill/>
+          <a:ln w="0">
+            <a:noFill/>
+            <a:prstDash val="solid"/>
+          </a:ln>
+        </p:spPr>
+        <p:txBody>
+          <a:bodyPr wrap="square" lIns="0" tIns="0" rIns="0" bIns="0" anchor="t">
+            <a:normAutofit fontScale="100000"/>
+          </a:bodyPr>
+          <a:lstStyle/>
+          <a:p>
+            <a:pPr algn="l">
+              <a:lnSpc>
+                <a:spcPct val="100000"/>
+              </a:lnSpc>
+              <a:buNone/>
+            </a:pPr>
+            <a:r>
+              <a:rPr sz="750" b="1" i="0">
+                <a:solidFill>
+                  <a:srgbClr val="9D4E24"/>
+                </a:solidFill>
+                <a:latin typeface="Arial"/>
+                <a:ea typeface="Arial"/>
+                <a:cs typeface="Arial"/>
+              </a:rPr>
+              <a:t>INDEPENDENT COVERAGE — FORBES, JUL 5, 2026:   </a:t>
+            </a:r>
+            <a:r>
+              <a:rPr sz="820" b="1" i="1">
+                <a:solidFill>
+                  <a:srgbClr val="17191C"/>
+                </a:solidFill>
+                <a:latin typeface="Arial"/>
+                <a:ea typeface="Arial"/>
+                <a:cs typeface="Arial"/>
+              </a:rPr>
+              <a:t>“AI Data Centers Are Set To Electrify This $13 Billion Family’s 76-Year-Old Company”</a:t>
+            </a:r>
+          </a:p>
+        </p:txBody>
+      </p:sp>
+      <p:sp>
+        <p:nvSpPr>
+          <p:cNvPr id="146" name=""/>
+          <p:cNvSpPr>
+            <a:spLocks noGrp="1"/>
+          </p:cNvSpPr>
+          <p:nvPr/>
+        </p:nvSpPr>
+        <p:spPr>
+          <a:xfrm>
+            <a:off x="719138" y="6260000"/>
+            <a:ext cx="10753724" cy="520000"/>
+          </a:xfrm>
+          <a:prstGeom prst="rect">
+            <a:avLst/>
+          </a:prstGeom>
+          <a:solidFill>
+            <a:srgbClr val="17191C"/>
+          </a:solidFill>
+          <a:ln w="0">
+            <a:noFill/>
+            <a:prstDash val="solid"/>
+          </a:ln>
+        </p:spPr>
+      </p:sp>
+      <p:sp>
+        <p:nvSpPr>
+          <p:cNvPr id="147" name=""/>
+          <p:cNvSpPr>
+            <a:spLocks noGrp="1"/>
+          </p:cNvSpPr>
+          <p:nvPr/>
+        </p:nvSpPr>
+        <p:spPr>
+          <a:xfrm>
+            <a:off x="833438" y="6320000"/>
+            <a:ext cx="3363908" cy="180000"/>
+          </a:xfrm>
+          <a:prstGeom prst="rect">
+            <a:avLst/>
+          </a:prstGeom>
+          <a:noFill/>
+          <a:ln w="0">
+            <a:noFill/>
+            <a:prstDash val="solid"/>
+          </a:ln>
+        </p:spPr>
+        <p:txBody>
+          <a:bodyPr wrap="square" lIns="0" tIns="0" rIns="0" bIns="0" anchor="t">
+            <a:normAutofit fontScale="100000"/>
+          </a:bodyPr>
+          <a:lstStyle/>
+          <a:p>
+            <a:pPr algn="l">
+              <a:lnSpc>
+                <a:spcPct val="100000"/>
+              </a:lnSpc>
+              <a:buNone/>
+            </a:pPr>
+            <a:r>
+              <a:rPr sz="650" b="1" i="0">
+                <a:solidFill>
+                  <a:srgbClr val="C9783E"/>
+                </a:solidFill>
+                <a:latin typeface="Arial"/>
+                <a:ea typeface="Arial"/>
+                <a:cs typeface="Arial"/>
+              </a:rPr>
+              <a:t>COPPER TECHNOLOGY</a:t>
+            </a:r>
+          </a:p>
+        </p:txBody>
+      </p:sp>
+      <p:sp>
+        <p:nvSpPr>
+          <p:cNvPr id="148" name=""/>
+          <p:cNvSpPr>
+            <a:spLocks noGrp="1"/>
+          </p:cNvSpPr>
+          <p:nvPr/>
+        </p:nvSpPr>
+        <p:spPr>
+          <a:xfrm>
+            <a:off x="833438" y="6500000"/>
+            <a:ext cx="3363908" cy="260000"/>
+          </a:xfrm>
+          <a:prstGeom prst="rect">
+            <a:avLst/>
+          </a:prstGeom>
+          <a:noFill/>
+          <a:ln w="0">
+            <a:noFill/>
+            <a:prstDash val="solid"/>
+          </a:ln>
+        </p:spPr>
+        <p:txBody>
+          <a:bodyPr wrap="square" lIns="0" tIns="0" rIns="0" bIns="0" anchor="t">
+            <a:normAutofit fontScale="100000"/>
+          </a:bodyPr>
+          <a:lstStyle/>
+          <a:p>
+            <a:pPr algn="l">
+              <a:lnSpc>
+                <a:spcPct val="102000"/>
+              </a:lnSpc>
+              <a:buNone/>
+            </a:pPr>
+            <a:r>
+              <a:rPr sz="780" b="1" i="0">
+                <a:solidFill>
+                  <a:srgbClr val="FFFFFF"/>
+                </a:solidFill>
+                <a:latin typeface="Arial"/>
+                <a:ea typeface="Arial"/>
+                <a:cs typeface="Arial"/>
+              </a:rPr>
+              <a:t>Half of the world's copper rod passes through a Southwire SCR® system.</a:t>
+            </a:r>
+          </a:p>
+        </p:txBody>
+      </p:sp>
+      <p:sp>
+        <p:nvSpPr>
+          <p:cNvPr id="149" name=""/>
+          <p:cNvSpPr>
+            <a:spLocks noGrp="1"/>
+          </p:cNvSpPr>
+          <p:nvPr/>
+        </p:nvSpPr>
+        <p:spPr>
+          <a:xfrm>
+            <a:off x="4311646" y="6320000"/>
+            <a:ext cx="3363908" cy="180000"/>
+          </a:xfrm>
+          <a:prstGeom prst="rect">
+            <a:avLst/>
+          </a:prstGeom>
+          <a:noFill/>
+          <a:ln w="0">
+            <a:noFill/>
+            <a:prstDash val="solid"/>
+          </a:ln>
+        </p:spPr>
+        <p:txBody>
+          <a:bodyPr wrap="square" lIns="0" tIns="0" rIns="0" bIns="0" anchor="t">
+            <a:normAutofit fontScale="100000"/>
+          </a:bodyPr>
+          <a:lstStyle/>
+          <a:p>
+            <a:pPr algn="l">
+              <a:lnSpc>
+                <a:spcPct val="100000"/>
+              </a:lnSpc>
+              <a:buNone/>
+            </a:pPr>
+            <a:r>
+              <a:rPr sz="650" b="1" i="0">
+                <a:solidFill>
+                  <a:srgbClr val="C9783E"/>
+                </a:solidFill>
+                <a:latin typeface="Arial"/>
+                <a:ea typeface="Arial"/>
+                <a:cs typeface="Arial"/>
+              </a:rPr>
+              <a:t>U.S. POWER GRID</a:t>
+            </a:r>
+          </a:p>
+        </p:txBody>
+      </p:sp>
+      <p:sp>
+        <p:nvSpPr>
+          <p:cNvPr id="150" name=""/>
+          <p:cNvSpPr>
+            <a:spLocks noGrp="1"/>
+          </p:cNvSpPr>
+          <p:nvPr/>
+        </p:nvSpPr>
+        <p:spPr>
+          <a:xfrm>
+            <a:off x="4311646" y="6500000"/>
+            <a:ext cx="3363908" cy="260000"/>
+          </a:xfrm>
+          <a:prstGeom prst="rect">
+            <a:avLst/>
+          </a:prstGeom>
+          <a:noFill/>
+          <a:ln w="0">
+            <a:noFill/>
+            <a:prstDash val="solid"/>
+          </a:ln>
+        </p:spPr>
+        <p:txBody>
+          <a:bodyPr wrap="square" lIns="0" tIns="0" rIns="0" bIns="0" anchor="t">
+            <a:normAutofit fontScale="100000"/>
+          </a:bodyPr>
+          <a:lstStyle/>
+          <a:p>
+            <a:pPr algn="l">
+              <a:lnSpc>
+                <a:spcPct val="102000"/>
+              </a:lnSpc>
+              <a:buNone/>
+            </a:pPr>
+            <a:r>
+              <a:rPr sz="780" b="1" i="0">
+                <a:solidFill>
+                  <a:srgbClr val="FFFFFF"/>
+                </a:solidFill>
+                <a:latin typeface="Arial"/>
+                <a:ea typeface="Arial"/>
+                <a:cs typeface="Arial"/>
+              </a:rPr>
+              <a:t>We produce half of the wire and cable that moves U.S. electricity.</a:t>
+            </a:r>
+          </a:p>
+        </p:txBody>
+      </p:sp>
+      <p:sp>
+        <p:nvSpPr>
+          <p:cNvPr id="151" name=""/>
+          <p:cNvSpPr>
+            <a:spLocks noGrp="1"/>
+          </p:cNvSpPr>
+          <p:nvPr/>
+        </p:nvSpPr>
+        <p:spPr>
+          <a:xfrm>
+            <a:off x="7789854" y="6320000"/>
+            <a:ext cx="3363908" cy="180000"/>
+          </a:xfrm>
+          <a:prstGeom prst="rect">
+            <a:avLst/>
+          </a:prstGeom>
+          <a:noFill/>
+          <a:ln w="0">
+            <a:noFill/>
+            <a:prstDash val="solid"/>
+          </a:ln>
+        </p:spPr>
+        <p:txBody>
+          <a:bodyPr wrap="square" lIns="0" tIns="0" rIns="0" bIns="0" anchor="t">
+            <a:normAutofit fontScale="100000"/>
+          </a:bodyPr>
+          <a:lstStyle/>
+          <a:p>
+            <a:pPr algn="l">
+              <a:lnSpc>
+                <a:spcPct val="100000"/>
+              </a:lnSpc>
+              <a:buNone/>
+            </a:pPr>
+            <a:r>
+              <a:rPr sz="650" b="1" i="0">
+                <a:solidFill>
+                  <a:srgbClr val="C9783E"/>
+                </a:solidFill>
+                <a:latin typeface="Arial"/>
+                <a:ea typeface="Arial"/>
+                <a:cs typeface="Arial"/>
+              </a:rPr>
+              <a:t>AMERICAN HOMES</a:t>
+            </a:r>
+          </a:p>
+        </p:txBody>
+      </p:sp>
+      <p:sp>
+        <p:nvSpPr>
+          <p:cNvPr id="152" name=""/>
+          <p:cNvSpPr>
+            <a:spLocks noGrp="1"/>
+          </p:cNvSpPr>
+          <p:nvPr/>
+        </p:nvSpPr>
+        <p:spPr>
+          <a:xfrm>
+            <a:off x="7789854" y="6500000"/>
+            <a:ext cx="3363908" cy="260000"/>
+          </a:xfrm>
+          <a:prstGeom prst="rect">
+            <a:avLst/>
+          </a:prstGeom>
+          <a:noFill/>
+          <a:ln w="0">
+            <a:noFill/>
+            <a:prstDash val="solid"/>
+          </a:ln>
+        </p:spPr>
+        <p:txBody>
+          <a:bodyPr wrap="square" lIns="0" tIns="0" rIns="0" bIns="0" anchor="t">
+            <a:normAutofit fontScale="100000"/>
+          </a:bodyPr>
+          <a:lstStyle/>
+          <a:p>
+            <a:pPr algn="l">
+              <a:lnSpc>
+                <a:spcPct val="102000"/>
+              </a:lnSpc>
+              <a:buNone/>
+            </a:pPr>
+            <a:r>
+              <a:rPr sz="780" b="1" i="0">
+                <a:solidFill>
+                  <a:srgbClr val="FFFFFF"/>
+                </a:solidFill>
+                <a:latin typeface="Arial"/>
+                <a:ea typeface="Arial"/>
+                <a:cs typeface="Arial"/>
+              </a:rPr>
+              <a:t>Half of American homes contain wiring produced by Southwire.</a:t>
             </a:r>
           </a:p>
         </p:txBody>

</xml_diff>

<commit_message>
Add live Forbes link on A1 and References appendix (A16)
A1's coverage line now hyperlinks to the Forbes article. New A16 lists
all leave-behind documents mapped to their appendices, clickable
southwire.com references, the credited Forbes cover image, and the
public fact base. 27 slides; exports regenerated.

Co-Authored-By: Claude Fable 5 <noreply@anthropic.com>
Claude-Session: https://claude.ai/code/session_01DUeyPCeDvcPsyTcH6oQXEK
</commit_message>
<xml_diff>
--- a/teaser-rework/Southwire_NRG_Protecting_Time_to_Power_Rev17.pptx
+++ b/teaser-rework/Southwire_NRG_Protecting_Time_to_Power_Rev17.pptx
@@ -31,6 +31,7 @@
     <p:sldId id="278" r:id="rId24"/>
     <p:sldId id="279" r:id="rId25"/>
     <p:sldId id="280" r:id="rId31"/>
+    <p:sldId id="282" r:id="rId33"/>
   </p:sldIdLst>
   <p:notesMasterIdLst>
     <p:notesMasterId r:id="rId26"/>
@@ -24861,15 +24862,28 @@
               <a:t>INDEPENDENT COVERAGE — FORBES, JUL 5, 2026:   </a:t>
             </a:r>
             <a:r>
-              <a:rPr sz="820" b="1" i="1">
+              <a:rPr sz="820" b="1" i="1" u="sng">
                 <a:solidFill>
                   <a:srgbClr val="17191C"/>
                 </a:solidFill>
                 <a:latin typeface="Arial"/>
                 <a:ea typeface="Arial"/>
                 <a:cs typeface="Arial"/>
+                <a:hlinkClick r:id="Rforbes"/>
               </a:rPr>
               <a:t>“AI Data Centers Are Set To Electrify This $13 Billion Family’s 76-Year-Old Company”</a:t>
+            </a:r>
+            <a:r>
+              <a:rPr sz="750" b="1" i="0">
+                <a:solidFill>
+                  <a:srgbClr val="9D4E24"/>
+                </a:solidFill>
+                <a:latin typeface="Arial"/>
+                <a:ea typeface="Arial"/>
+                <a:cs typeface="Arial"/>
+                <a:hlinkClick r:id="Rforbes"/>
+              </a:rPr>
+              <a:t>   READ ON FORBES ↗</a:t>
             </a:r>
           </a:p>
         </p:txBody>
@@ -25183,6 +25197,1274 @@
                 <a:cs typeface="Arial"/>
               </a:rPr>
               <a:t>Half of American homes contain wiring produced by Southwire.</a:t>
+            </a:r>
+          </a:p>
+        </p:txBody>
+      </p:sp>
+    </p:spTree>
+  </p:cSld>
+</p:sld>
+</file>
+
+<file path=ppt/slides/slide27.xml><?xml version="1.0" encoding="utf-8"?>
+<p:sld xmlns:p="http://schemas.openxmlformats.org/presentationml/2006/main" xmlns:a="http://schemas.openxmlformats.org/drawingml/2006/main" xmlns:r="http://schemas.openxmlformats.org/officeDocument/2006/relationships">
+  <p:cSld>
+    <p:bg>
+      <p:bgPr>
+        <a:solidFill>
+          <a:srgbClr val="F6F3EE"/>
+        </a:solidFill>
+      </p:bgPr>
+    </p:bg>
+    <p:spTree>
+      <p:nvGrpSpPr>
+        <p:cNvPr id="1" name=""/>
+        <p:cNvGrpSpPr/>
+        <p:nvPr/>
+      </p:nvGrpSpPr>
+      <p:grpSpPr>
+        <a:xfrm/>
+      </p:grpSpPr>
+      <p:sp>
+        <p:nvSpPr>
+          <p:cNvPr id="101" name=""/>
+          <p:cNvSpPr>
+            <a:spLocks noGrp="1"/>
+          </p:cNvSpPr>
+          <p:nvPr/>
+        </p:nvSpPr>
+        <p:spPr>
+          <a:xfrm>
+            <a:off x="0" y="0"/>
+            <a:ext cx="12192000" cy="57150"/>
+          </a:xfrm>
+          <a:prstGeom prst="rect">
+            <a:avLst/>
+          </a:prstGeom>
+          <a:solidFill>
+            <a:srgbClr val="C9783E"/>
+          </a:solidFill>
+          <a:ln w="0">
+            <a:noFill/>
+            <a:prstDash val="solid"/>
+          </a:ln>
+        </p:spPr>
+      </p:sp>
+      <p:pic>
+        <p:nvPicPr>
+          <p:cNvPr id="102" name=""/>
+          <p:cNvPicPr>
+            <a:picLocks noChangeAspect="1"/>
+          </p:cNvPicPr>
+          <p:nvPr/>
+        </p:nvPicPr>
+        <p:blipFill>
+          <a:blip r:embed="rId1"/>
+          <a:stretch/>
+        </p:blipFill>
+        <p:spPr>
+          <a:xfrm>
+            <a:off x="719138" y="200025"/>
+            <a:ext cx="2066925" cy="590550"/>
+          </a:xfrm>
+          <a:prstGeom prst="rect">
+            <a:avLst/>
+          </a:prstGeom>
+        </p:spPr>
+      </p:pic>
+      <p:sp>
+        <p:nvSpPr>
+          <p:cNvPr id="103" name=""/>
+          <p:cNvSpPr>
+            <a:spLocks noGrp="1"/>
+          </p:cNvSpPr>
+          <p:nvPr/>
+        </p:nvSpPr>
+        <p:spPr>
+          <a:xfrm>
+            <a:off x="7325360" y="323850"/>
+            <a:ext cx="3600000" cy="228600"/>
+          </a:xfrm>
+          <a:prstGeom prst="rect">
+            <a:avLst/>
+          </a:prstGeom>
+          <a:noFill/>
+          <a:ln w="0">
+            <a:noFill/>
+            <a:prstDash val="solid"/>
+          </a:ln>
+        </p:spPr>
+        <p:txBody>
+          <a:bodyPr wrap="square" lIns="0" tIns="0" rIns="0" bIns="0" anchor="t">
+            <a:normAutofit fontScale="100000"/>
+          </a:bodyPr>
+          <a:lstStyle/>
+          <a:p>
+            <a:pPr algn="r">
+              <a:lnSpc>
+                <a:spcPct val="100000"/>
+              </a:lnSpc>
+              <a:buNone/>
+            </a:pPr>
+            <a:r>
+              <a:rPr sz="820" b="1" i="0">
+                <a:solidFill>
+                  <a:srgbClr val="9D4E24"/>
+                </a:solidFill>
+                <a:latin typeface="Arial"/>
+                <a:ea typeface="Arial"/>
+                <a:cs typeface="Arial"/>
+              </a:rPr>
+              <a:t>APPENDIX A16 · RESOURCES</a:t>
+            </a:r>
+          </a:p>
+        </p:txBody>
+      </p:sp>
+      <p:sp>
+        <p:nvSpPr>
+          <p:cNvPr id="104" name=""/>
+          <p:cNvSpPr>
+            <a:spLocks noGrp="1"/>
+          </p:cNvSpPr>
+          <p:nvPr/>
+        </p:nvSpPr>
+        <p:spPr>
+          <a:xfrm>
+            <a:off x="11060000" y="323850"/>
+            <a:ext cx="600000" cy="228600"/>
+          </a:xfrm>
+          <a:prstGeom prst="rect">
+            <a:avLst/>
+          </a:prstGeom>
+          <a:noFill/>
+          <a:ln w="0">
+            <a:noFill/>
+            <a:prstDash val="solid"/>
+          </a:ln>
+        </p:spPr>
+        <p:txBody>
+          <a:bodyPr wrap="square" lIns="0" tIns="0" rIns="0" bIns="0" anchor="t">
+            <a:normAutofit fontScale="100000"/>
+          </a:bodyPr>
+          <a:lstStyle/>
+          <a:p>
+            <a:pPr algn="r">
+              <a:lnSpc>
+                <a:spcPct val="100000"/>
+              </a:lnSpc>
+              <a:buNone/>
+            </a:pPr>
+            <a:r>
+              <a:rPr sz="820" b="1" i="0">
+                <a:solidFill>
+                  <a:srgbClr val="8B9094"/>
+                </a:solidFill>
+                <a:latin typeface="Arial"/>
+                <a:ea typeface="Arial"/>
+                <a:cs typeface="Arial"/>
+              </a:rPr>
+              <a:t>27</a:t>
+            </a:r>
+          </a:p>
+        </p:txBody>
+      </p:sp>
+      <p:sp>
+        <p:nvSpPr>
+          <p:cNvPr id="105" name=""/>
+          <p:cNvSpPr>
+            <a:spLocks noGrp="1"/>
+          </p:cNvSpPr>
+          <p:nvPr/>
+        </p:nvSpPr>
+        <p:spPr>
+          <a:xfrm>
+            <a:off x="719138" y="1005840"/>
+            <a:ext cx="8500000" cy="228600"/>
+          </a:xfrm>
+          <a:prstGeom prst="rect">
+            <a:avLst/>
+          </a:prstGeom>
+          <a:noFill/>
+          <a:ln w="0">
+            <a:noFill/>
+            <a:prstDash val="solid"/>
+          </a:ln>
+        </p:spPr>
+        <p:txBody>
+          <a:bodyPr wrap="square" lIns="0" tIns="0" rIns="0" bIns="0" anchor="t">
+            <a:normAutofit fontScale="100000"/>
+          </a:bodyPr>
+          <a:lstStyle/>
+          <a:p>
+            <a:pPr algn="l">
+              <a:lnSpc>
+                <a:spcPct val="100000"/>
+              </a:lnSpc>
+              <a:buNone/>
+            </a:pPr>
+            <a:r>
+              <a:rPr sz="880" b="1" i="0">
+                <a:solidFill>
+                  <a:srgbClr val="C9783E"/>
+                </a:solidFill>
+                <a:latin typeface="Arial"/>
+                <a:ea typeface="Arial"/>
+                <a:cs typeface="Arial"/>
+              </a:rPr>
+              <a:t>DOCUMENTS AND REFERENCES BEHIND THIS DECK</a:t>
+            </a:r>
+          </a:p>
+        </p:txBody>
+      </p:sp>
+      <p:sp>
+        <p:nvSpPr>
+          <p:cNvPr id="106" name=""/>
+          <p:cNvSpPr>
+            <a:spLocks noGrp="1"/>
+          </p:cNvSpPr>
+          <p:nvPr/>
+        </p:nvSpPr>
+        <p:spPr>
+          <a:xfrm>
+            <a:off x="719138" y="1280160"/>
+            <a:ext cx="10753724" cy="500000"/>
+          </a:xfrm>
+          <a:prstGeom prst="rect">
+            <a:avLst/>
+          </a:prstGeom>
+          <a:noFill/>
+          <a:ln w="0">
+            <a:noFill/>
+            <a:prstDash val="solid"/>
+          </a:ln>
+        </p:spPr>
+        <p:txBody>
+          <a:bodyPr wrap="square" lIns="0" tIns="0" rIns="0" bIns="0" anchor="t">
+            <a:normAutofit fontScale="100000"/>
+          </a:bodyPr>
+          <a:lstStyle/>
+          <a:p>
+            <a:pPr algn="l">
+              <a:lnSpc>
+                <a:spcPct val="104000"/>
+              </a:lnSpc>
+              <a:buNone/>
+            </a:pPr>
+            <a:r>
+              <a:rPr sz="2850" b="1" i="0">
+                <a:solidFill>
+                  <a:srgbClr val="17191C"/>
+                </a:solidFill>
+                <a:latin typeface="Arial"/>
+                <a:ea typeface="Arial"/>
+                <a:cs typeface="Arial"/>
+              </a:rPr>
+              <a:t>Everything referenced here exists as a document you can have.</a:t>
+            </a:r>
+          </a:p>
+        </p:txBody>
+      </p:sp>
+      <p:sp>
+        <p:nvSpPr>
+          <p:cNvPr id="107" name=""/>
+          <p:cNvSpPr>
+            <a:spLocks noGrp="1"/>
+          </p:cNvSpPr>
+          <p:nvPr/>
+        </p:nvSpPr>
+        <p:spPr>
+          <a:xfrm>
+            <a:off x="719138" y="2103120"/>
+            <a:ext cx="6200000" cy="228600"/>
+          </a:xfrm>
+          <a:prstGeom prst="rect">
+            <a:avLst/>
+          </a:prstGeom>
+          <a:noFill/>
+          <a:ln w="0">
+            <a:noFill/>
+            <a:prstDash val="solid"/>
+          </a:ln>
+        </p:spPr>
+        <p:txBody>
+          <a:bodyPr wrap="square" lIns="0" tIns="0" rIns="0" bIns="0" anchor="t">
+            <a:normAutofit fontScale="100000"/>
+          </a:bodyPr>
+          <a:lstStyle/>
+          <a:p>
+            <a:pPr algn="l">
+              <a:lnSpc>
+                <a:spcPct val="100000"/>
+              </a:lnSpc>
+              <a:buNone/>
+            </a:pPr>
+            <a:r>
+              <a:rPr sz="880" b="1" i="0">
+                <a:solidFill>
+                  <a:srgbClr val="9D4E24"/>
+                </a:solidFill>
+                <a:latin typeface="Arial"/>
+                <a:ea typeface="Arial"/>
+                <a:cs typeface="Arial"/>
+              </a:rPr>
+              <a:t>LEAVE-BEHIND DOCUMENTS — AVAILABLE ON REQUEST</a:t>
+            </a:r>
+          </a:p>
+        </p:txBody>
+      </p:sp>
+      <p:sp>
+        <p:nvSpPr>
+          <p:cNvPr id="108" name=""/>
+          <p:cNvSpPr>
+            <a:spLocks noGrp="1"/>
+          </p:cNvSpPr>
+          <p:nvPr/>
+        </p:nvSpPr>
+        <p:spPr>
+          <a:xfrm>
+            <a:off x="719138" y="2423160"/>
+            <a:ext cx="6200000" cy="620000"/>
+          </a:xfrm>
+          <a:prstGeom prst="rect">
+            <a:avLst/>
+          </a:prstGeom>
+          <a:noFill/>
+          <a:ln w="0">
+            <a:noFill/>
+            <a:prstDash val="solid"/>
+          </a:ln>
+        </p:spPr>
+        <p:txBody>
+          <a:bodyPr wrap="square" lIns="0" tIns="0" rIns="0" bIns="0" anchor="t">
+            <a:normAutofit fontScale="100000"/>
+          </a:bodyPr>
+          <a:lstStyle/>
+          <a:p>
+            <a:pPr algn="l">
+              <a:lnSpc>
+                <a:spcPct val="105000"/>
+              </a:lnSpc>
+              <a:buNone/>
+            </a:pPr>
+            <a:r>
+              <a:rPr sz="900" b="1" i="0">
+                <a:solidFill>
+                  <a:srgbClr val="17191C"/>
+                </a:solidFill>
+                <a:latin typeface="Arial"/>
+                <a:ea typeface="Arial"/>
+                <a:cs typeface="Arial"/>
+              </a:rPr>
+              <a:t>IPP Cable Catalogue</a:t>
+            </a:r>
+            <a:r>
+              <a:rPr sz="900" b="0" i="0">
+                <a:solidFill>
+                  <a:srgbClr val="6A6F73"/>
+                </a:solidFill>
+                <a:latin typeface="Arial"/>
+                <a:ea typeface="Arial"/>
+                <a:cs typeface="Arial"/>
+              </a:rPr>
+              <a:t> — the plant platform: HVUD high-voltage underground classes 69–400 kV, MV-105 NL-EPR, balance of system, and the pre-FEED engagement model. Behind A13.</a:t>
+            </a:r>
+          </a:p>
+        </p:txBody>
+      </p:sp>
+      <p:sp>
+        <p:nvSpPr>
+          <p:cNvPr id="109" name=""/>
+          <p:cNvSpPr>
+            <a:spLocks noGrp="1"/>
+          </p:cNvSpPr>
+          <p:nvPr/>
+        </p:nvSpPr>
+        <p:spPr>
+          <a:xfrm>
+            <a:off x="719138" y="3063240"/>
+            <a:ext cx="6200000" cy="620000"/>
+          </a:xfrm>
+          <a:prstGeom prst="rect">
+            <a:avLst/>
+          </a:prstGeom>
+          <a:noFill/>
+          <a:ln w="0">
+            <a:noFill/>
+            <a:prstDash val="solid"/>
+          </a:ln>
+        </p:spPr>
+        <p:txBody>
+          <a:bodyPr wrap="square" lIns="0" tIns="0" rIns="0" bIns="0" anchor="t">
+            <a:normAutofit fontScale="100000"/>
+          </a:bodyPr>
+          <a:lstStyle/>
+          <a:p>
+            <a:pPr algn="l">
+              <a:lnSpc>
+                <a:spcPct val="105000"/>
+              </a:lnSpc>
+              <a:buNone/>
+            </a:pPr>
+            <a:r>
+              <a:rPr sz="900" b="1" i="0">
+                <a:solidFill>
+                  <a:srgbClr val="17191C"/>
+                </a:solidFill>
+                <a:latin typeface="Arial"/>
+                <a:ea typeface="Arial"/>
+                <a:cs typeface="Arial"/>
+              </a:rPr>
+              <a:t>Packaged Power e-Catalogue</a:t>
+            </a:r>
+            <a:r>
+              <a:rPr sz="900" b="0" i="0">
+                <a:solidFill>
+                  <a:srgbClr val="6A6F73"/>
+                </a:solidFill>
+                <a:latin typeface="Arial"/>
+                <a:ea typeface="Arial"/>
+                <a:cs typeface="Arial"/>
+              </a:rPr>
+              <a:t> — wire and cable for skids, e-houses, containerized substations, BESS and gensets; SIMpull, pre-cuts and kitting. Behind A13 and the skid scenario (A8).</a:t>
+            </a:r>
+          </a:p>
+        </p:txBody>
+      </p:sp>
+      <p:sp>
+        <p:nvSpPr>
+          <p:cNvPr id="110" name=""/>
+          <p:cNvSpPr>
+            <a:spLocks noGrp="1"/>
+          </p:cNvSpPr>
+          <p:nvPr/>
+        </p:nvSpPr>
+        <p:spPr>
+          <a:xfrm>
+            <a:off x="719138" y="3703320"/>
+            <a:ext cx="6200000" cy="620000"/>
+          </a:xfrm>
+          <a:prstGeom prst="rect">
+            <a:avLst/>
+          </a:prstGeom>
+          <a:noFill/>
+          <a:ln w="0">
+            <a:noFill/>
+            <a:prstDash val="solid"/>
+          </a:ln>
+        </p:spPr>
+        <p:txBody>
+          <a:bodyPr wrap="square" lIns="0" tIns="0" rIns="0" bIns="0" anchor="t">
+            <a:normAutofit fontScale="100000"/>
+          </a:bodyPr>
+          <a:lstStyle/>
+          <a:p>
+            <a:pPr algn="l">
+              <a:lnSpc>
+                <a:spcPct val="105000"/>
+              </a:lnSpc>
+              <a:buNone/>
+            </a:pPr>
+            <a:r>
+              <a:rPr sz="900" b="1" i="0">
+                <a:solidFill>
+                  <a:srgbClr val="17191C"/>
+                </a:solidFill>
+                <a:latin typeface="Arial"/>
+                <a:ea typeface="Arial"/>
+                <a:cs typeface="Arial"/>
+              </a:rPr>
+              <a:t>Rejuvenation, Brownfield &amp; Service Offerings for IPP Portfolios</a:t>
+            </a:r>
+            <a:r>
+              <a:rPr sz="900" b="0" i="0">
+                <a:solidFill>
+                  <a:srgbClr val="6A6F73"/>
+                </a:solidFill>
+                <a:latin typeface="Arial"/>
+                <a:ea typeface="Arial"/>
+                <a:cs typeface="Arial"/>
+              </a:rPr>
+              <a:t> — the operating-fleet program: spine rejuvenation, cable replacement, repower support, condition programs. Behind A14.</a:t>
+            </a:r>
+          </a:p>
+        </p:txBody>
+      </p:sp>
+      <p:sp>
+        <p:nvSpPr>
+          <p:cNvPr id="111" name=""/>
+          <p:cNvSpPr>
+            <a:spLocks noGrp="1"/>
+          </p:cNvSpPr>
+          <p:nvPr/>
+        </p:nvSpPr>
+        <p:spPr>
+          <a:xfrm>
+            <a:off x="719138" y="4343400"/>
+            <a:ext cx="6200000" cy="620000"/>
+          </a:xfrm>
+          <a:prstGeom prst="rect">
+            <a:avLst/>
+          </a:prstGeom>
+          <a:noFill/>
+          <a:ln w="0">
+            <a:noFill/>
+            <a:prstDash val="solid"/>
+          </a:ln>
+        </p:spPr>
+        <p:txBody>
+          <a:bodyPr wrap="square" lIns="0" tIns="0" rIns="0" bIns="0" anchor="t">
+            <a:normAutofit fontScale="100000"/>
+          </a:bodyPr>
+          <a:lstStyle/>
+          <a:p>
+            <a:pPr algn="l">
+              <a:lnSpc>
+                <a:spcPct val="105000"/>
+              </a:lnSpc>
+              <a:buNone/>
+            </a:pPr>
+            <a:r>
+              <a:rPr sz="900" b="1" i="0">
+                <a:solidFill>
+                  <a:srgbClr val="17191C"/>
+                </a:solidFill>
+                <a:latin typeface="Arial"/>
+                <a:ea typeface="Arial"/>
+                <a:cs typeface="Arial"/>
+              </a:rPr>
+              <a:t>Integrated Power Infrastructure e-Catalog</a:t>
+            </a:r>
+            <a:r>
+              <a:rPr sz="900" b="0" i="0">
+                <a:solidFill>
+                  <a:srgbClr val="6A6F73"/>
+                </a:solidFill>
+                <a:latin typeface="Arial"/>
+                <a:ea typeface="Arial"/>
+                <a:cs typeface="Arial"/>
+              </a:rPr>
+              <a:t> — pre-EPC master planning workshop, spine architecture, procurement risk register, finance and ESG documentation. Behind A12.</a:t>
+            </a:r>
+          </a:p>
+        </p:txBody>
+      </p:sp>
+      <p:sp>
+        <p:nvSpPr>
+          <p:cNvPr id="112" name=""/>
+          <p:cNvSpPr>
+            <a:spLocks noGrp="1"/>
+          </p:cNvSpPr>
+          <p:nvPr/>
+        </p:nvSpPr>
+        <p:spPr>
+          <a:xfrm>
+            <a:off x="719138" y="4983480"/>
+            <a:ext cx="6200000" cy="620000"/>
+          </a:xfrm>
+          <a:prstGeom prst="rect">
+            <a:avLst/>
+          </a:prstGeom>
+          <a:noFill/>
+          <a:ln w="0">
+            <a:noFill/>
+            <a:prstDash val="solid"/>
+          </a:ln>
+        </p:spPr>
+        <p:txBody>
+          <a:bodyPr wrap="square" lIns="0" tIns="0" rIns="0" bIns="0" anchor="t">
+            <a:normAutofit fontScale="100000"/>
+          </a:bodyPr>
+          <a:lstStyle/>
+          <a:p>
+            <a:pPr algn="l">
+              <a:lnSpc>
+                <a:spcPct val="105000"/>
+              </a:lnSpc>
+              <a:buNone/>
+            </a:pPr>
+            <a:r>
+              <a:rPr sz="900" b="1" i="0">
+                <a:solidFill>
+                  <a:srgbClr val="17191C"/>
+                </a:solidFill>
+                <a:latin typeface="Arial"/>
+                <a:ea typeface="Arial"/>
+                <a:cs typeface="Arial"/>
+              </a:rPr>
+              <a:t>SK-120 · Plant Zones &amp; Key Cable Applications</a:t>
+            </a:r>
+            <a:r>
+              <a:rPr sz="900" b="0" i="0">
+                <a:solidFill>
+                  <a:srgbClr val="6A6F73"/>
+                </a:solidFill>
+                <a:latin typeface="Arial"/>
+                <a:ea typeface="Arial"/>
+                <a:cs typeface="Arial"/>
+              </a:rPr>
+              <a:t> — the 34-inch site-walk poster: 16 zones, per-zone cable applications, routed 3×1 basis. Reproduced at A7.</a:t>
+            </a:r>
+          </a:p>
+        </p:txBody>
+      </p:sp>
+      <p:sp>
+        <p:nvSpPr>
+          <p:cNvPr id="113" name=""/>
+          <p:cNvSpPr>
+            <a:spLocks noGrp="1"/>
+          </p:cNvSpPr>
+          <p:nvPr/>
+        </p:nvSpPr>
+        <p:spPr>
+          <a:xfrm>
+            <a:off x="719138" y="5623560"/>
+            <a:ext cx="6200000" cy="620000"/>
+          </a:xfrm>
+          <a:prstGeom prst="rect">
+            <a:avLst/>
+          </a:prstGeom>
+          <a:noFill/>
+          <a:ln w="0">
+            <a:noFill/>
+            <a:prstDash val="solid"/>
+          </a:ln>
+        </p:spPr>
+        <p:txBody>
+          <a:bodyPr wrap="square" lIns="0" tIns="0" rIns="0" bIns="0" anchor="t">
+            <a:normAutofit fontScale="100000"/>
+          </a:bodyPr>
+          <a:lstStyle/>
+          <a:p>
+            <a:pPr algn="l">
+              <a:lnSpc>
+                <a:spcPct val="105000"/>
+              </a:lnSpc>
+              <a:buNone/>
+            </a:pPr>
+            <a:r>
+              <a:rPr sz="900" b="1" i="0">
+                <a:solidFill>
+                  <a:srgbClr val="17191C"/>
+                </a:solidFill>
+                <a:latin typeface="Arial"/>
+                <a:ea typeface="Arial"/>
+                <a:cs typeface="Arial"/>
+              </a:rPr>
+              <a:t>Cedar Bayou Unit 5 project reference</a:t>
+            </a:r>
+            <a:r>
+              <a:rPr sz="900" b="0" i="0">
+                <a:solidFill>
+                  <a:srgbClr val="6A6F73"/>
+                </a:solidFill>
+                <a:latin typeface="Arial"/>
+                <a:ea typeface="Arial"/>
+                <a:cs typeface="Arial"/>
+              </a:rPr>
+              <a:t> — public-record project facts and scope selections, validated Aug 2026. Behind A11.</a:t>
+            </a:r>
+          </a:p>
+        </p:txBody>
+      </p:sp>
+      <p:sp>
+        <p:nvSpPr>
+          <p:cNvPr id="114" name=""/>
+          <p:cNvSpPr>
+            <a:spLocks noGrp="1"/>
+          </p:cNvSpPr>
+          <p:nvPr/>
+        </p:nvSpPr>
+        <p:spPr>
+          <a:xfrm>
+            <a:off x="7300000" y="2103120"/>
+            <a:ext cx="4172862" cy="228600"/>
+          </a:xfrm>
+          <a:prstGeom prst="rect">
+            <a:avLst/>
+          </a:prstGeom>
+          <a:noFill/>
+          <a:ln w="0">
+            <a:noFill/>
+            <a:prstDash val="solid"/>
+          </a:ln>
+        </p:spPr>
+        <p:txBody>
+          <a:bodyPr wrap="square" lIns="0" tIns="0" rIns="0" bIns="0" anchor="t">
+            <a:normAutofit fontScale="100000"/>
+          </a:bodyPr>
+          <a:lstStyle/>
+          <a:p>
+            <a:pPr algn="l">
+              <a:lnSpc>
+                <a:spcPct val="100000"/>
+              </a:lnSpc>
+              <a:buNone/>
+            </a:pPr>
+            <a:r>
+              <a:rPr sz="880" b="1" i="0">
+                <a:solidFill>
+                  <a:srgbClr val="9D4E24"/>
+                </a:solidFill>
+                <a:latin typeface="Arial"/>
+                <a:ea typeface="Arial"/>
+                <a:cs typeface="Arial"/>
+              </a:rPr>
+              <a:t>PUBLIC REFERENCES</a:t>
+            </a:r>
+          </a:p>
+        </p:txBody>
+      </p:sp>
+      <p:sp>
+        <p:nvSpPr>
+          <p:cNvPr id="115" name=""/>
+          <p:cNvSpPr>
+            <a:spLocks noGrp="1"/>
+          </p:cNvSpPr>
+          <p:nvPr/>
+        </p:nvSpPr>
+        <p:spPr>
+          <a:xfrm>
+            <a:off x="7300000" y="2423160"/>
+            <a:ext cx="4172862" cy="260000"/>
+          </a:xfrm>
+          <a:prstGeom prst="rect">
+            <a:avLst/>
+          </a:prstGeom>
+          <a:noFill/>
+          <a:ln w="0">
+            <a:noFill/>
+            <a:prstDash val="solid"/>
+          </a:ln>
+        </p:spPr>
+        <p:txBody>
+          <a:bodyPr wrap="square" lIns="0" tIns="0" rIns="0" bIns="0" anchor="t">
+            <a:normAutofit fontScale="100000"/>
+          </a:bodyPr>
+          <a:lstStyle/>
+          <a:p>
+            <a:pPr algn="l">
+              <a:lnSpc>
+                <a:spcPct val="104000"/>
+              </a:lnSpc>
+              <a:buNone/>
+            </a:pPr>
+            <a:r>
+              <a:rPr sz="850" b="1" i="0" u="sng">
+                <a:solidFill>
+                  <a:srgbClr val="9D4E24"/>
+                </a:solidFill>
+                <a:latin typeface="Arial"/>
+                <a:ea typeface="Arial"/>
+                <a:cs typeface="Arial"/>
+                <a:hlinkClick r:id="Rsw1"/>
+              </a:rPr>
+              <a:t>southwire.com/services/project-services</a:t>
+            </a:r>
+            <a:r>
+              <a:rPr sz="850" b="0" i="0">
+                <a:solidFill>
+                  <a:srgbClr val="6A6F73"/>
+                </a:solidFill>
+                <a:latin typeface="Arial"/>
+                <a:ea typeface="Arial"/>
+                <a:cs typeface="Arial"/>
+              </a:rPr>
+              <a:t>  ·  Project services</a:t>
+            </a:r>
+          </a:p>
+        </p:txBody>
+      </p:sp>
+      <p:sp>
+        <p:nvSpPr>
+          <p:cNvPr id="116" name=""/>
+          <p:cNvSpPr>
+            <a:spLocks noGrp="1"/>
+          </p:cNvSpPr>
+          <p:nvPr/>
+        </p:nvSpPr>
+        <p:spPr>
+          <a:xfrm>
+            <a:off x="7300000" y="2743200"/>
+            <a:ext cx="4172862" cy="260000"/>
+          </a:xfrm>
+          <a:prstGeom prst="rect">
+            <a:avLst/>
+          </a:prstGeom>
+          <a:noFill/>
+          <a:ln w="0">
+            <a:noFill/>
+            <a:prstDash val="solid"/>
+          </a:ln>
+        </p:spPr>
+        <p:txBody>
+          <a:bodyPr wrap="square" lIns="0" tIns="0" rIns="0" bIns="0" anchor="t">
+            <a:normAutofit fontScale="100000"/>
+          </a:bodyPr>
+          <a:lstStyle/>
+          <a:p>
+            <a:pPr algn="l">
+              <a:lnSpc>
+                <a:spcPct val="104000"/>
+              </a:lnSpc>
+              <a:buNone/>
+            </a:pPr>
+            <a:r>
+              <a:rPr sz="850" b="1" i="0" u="sng">
+                <a:solidFill>
+                  <a:srgbClr val="9D4E24"/>
+                </a:solidFill>
+                <a:latin typeface="Arial"/>
+                <a:ea typeface="Arial"/>
+                <a:cs typeface="Arial"/>
+                <a:hlinkClick r:id="Rsw2"/>
+              </a:rPr>
+              <a:t>southwire.com/services</a:t>
+            </a:r>
+            <a:r>
+              <a:rPr sz="850" b="0" i="0">
+                <a:solidFill>
+                  <a:srgbClr val="6A6F73"/>
+                </a:solidFill>
+                <a:latin typeface="Arial"/>
+                <a:ea typeface="Arial"/>
+                <a:cs typeface="Arial"/>
+              </a:rPr>
+              <a:t>  ·  Services &amp; technical support</a:t>
+            </a:r>
+          </a:p>
+        </p:txBody>
+      </p:sp>
+      <p:sp>
+        <p:nvSpPr>
+          <p:cNvPr id="117" name=""/>
+          <p:cNvSpPr>
+            <a:spLocks noGrp="1"/>
+          </p:cNvSpPr>
+          <p:nvPr/>
+        </p:nvSpPr>
+        <p:spPr>
+          <a:xfrm>
+            <a:off x="7300000" y="3063240"/>
+            <a:ext cx="4172862" cy="260000"/>
+          </a:xfrm>
+          <a:prstGeom prst="rect">
+            <a:avLst/>
+          </a:prstGeom>
+          <a:noFill/>
+          <a:ln w="0">
+            <a:noFill/>
+            <a:prstDash val="solid"/>
+          </a:ln>
+        </p:spPr>
+        <p:txBody>
+          <a:bodyPr wrap="square" lIns="0" tIns="0" rIns="0" bIns="0" anchor="t">
+            <a:normAutofit fontScale="100000"/>
+          </a:bodyPr>
+          <a:lstStyle/>
+          <a:p>
+            <a:pPr algn="l">
+              <a:lnSpc>
+                <a:spcPct val="104000"/>
+              </a:lnSpc>
+              <a:buNone/>
+            </a:pPr>
+            <a:r>
+              <a:rPr sz="850" b="1" i="0" u="sng">
+                <a:solidFill>
+                  <a:srgbClr val="9D4E24"/>
+                </a:solidFill>
+                <a:latin typeface="Arial"/>
+                <a:ea typeface="Arial"/>
+                <a:cs typeface="Arial"/>
+                <a:hlinkClick r:id="Rsw3"/>
+              </a:rPr>
+              <a:t>southwire.com/sustainability/product-transparency</a:t>
+            </a:r>
+            <a:r>
+              <a:rPr sz="850" b="0" i="0">
+                <a:solidFill>
+                  <a:srgbClr val="6A6F73"/>
+                </a:solidFill>
+                <a:latin typeface="Arial"/>
+                <a:ea typeface="Arial"/>
+                <a:cs typeface="Arial"/>
+              </a:rPr>
+              <a:t>  ·  EPDs &amp; product transparency</a:t>
+            </a:r>
+          </a:p>
+        </p:txBody>
+      </p:sp>
+      <p:sp>
+        <p:nvSpPr>
+          <p:cNvPr id="118" name=""/>
+          <p:cNvSpPr>
+            <a:spLocks noGrp="1"/>
+          </p:cNvSpPr>
+          <p:nvPr/>
+        </p:nvSpPr>
+        <p:spPr>
+          <a:xfrm>
+            <a:off x="7300000" y="3383280"/>
+            <a:ext cx="4172862" cy="260000"/>
+          </a:xfrm>
+          <a:prstGeom prst="rect">
+            <a:avLst/>
+          </a:prstGeom>
+          <a:noFill/>
+          <a:ln w="0">
+            <a:noFill/>
+            <a:prstDash val="solid"/>
+          </a:ln>
+        </p:spPr>
+        <p:txBody>
+          <a:bodyPr wrap="square" lIns="0" tIns="0" rIns="0" bIns="0" anchor="t">
+            <a:normAutofit fontScale="100000"/>
+          </a:bodyPr>
+          <a:lstStyle/>
+          <a:p>
+            <a:pPr algn="l">
+              <a:lnSpc>
+                <a:spcPct val="104000"/>
+              </a:lnSpc>
+              <a:buNone/>
+            </a:pPr>
+            <a:r>
+              <a:rPr sz="850" b="1" i="0" u="sng">
+                <a:solidFill>
+                  <a:srgbClr val="9D4E24"/>
+                </a:solidFill>
+                <a:latin typeface="Arial"/>
+                <a:ea typeface="Arial"/>
+                <a:cs typeface="Arial"/>
+                <a:hlinkClick r:id="Rsw4"/>
+              </a:rPr>
+              <a:t>southwire.com/sustainability/doing-right</a:t>
+            </a:r>
+            <a:r>
+              <a:rPr sz="850" b="0" i="0">
+                <a:solidFill>
+                  <a:srgbClr val="6A6F73"/>
+                </a:solidFill>
+                <a:latin typeface="Arial"/>
+                <a:ea typeface="Arial"/>
+                <a:cs typeface="Arial"/>
+              </a:rPr>
+              <a:t>  ·  Responsible production</a:t>
+            </a:r>
+          </a:p>
+        </p:txBody>
+      </p:sp>
+      <p:sp>
+        <p:nvSpPr>
+          <p:cNvPr id="119" name=""/>
+          <p:cNvSpPr>
+            <a:spLocks noGrp="1"/>
+          </p:cNvSpPr>
+          <p:nvPr/>
+        </p:nvSpPr>
+        <p:spPr>
+          <a:xfrm>
+            <a:off x="7300000" y="3810000"/>
+            <a:ext cx="4172862" cy="9525"/>
+          </a:xfrm>
+          <a:prstGeom prst="rect">
+            <a:avLst/>
+          </a:prstGeom>
+          <a:solidFill>
+            <a:srgbClr val="D8D1C8"/>
+          </a:solidFill>
+          <a:ln w="0">
+            <a:noFill/>
+            <a:prstDash val="solid"/>
+          </a:ln>
+        </p:spPr>
+      </p:sp>
+      <p:pic>
+        <p:nvPicPr>
+          <p:cNvPr id="120" name=""/>
+          <p:cNvPicPr>
+            <a:picLocks noChangeAspect="1"/>
+          </p:cNvPicPr>
+          <p:nvPr/>
+        </p:nvPicPr>
+        <p:blipFill>
+          <a:blip r:embed="Rfimg"/>
+          <a:stretch/>
+        </p:blipFill>
+        <p:spPr>
+          <a:xfrm>
+            <a:off x="7300000" y="3930000"/>
+            <a:ext cx="1500000" cy="1038000"/>
+          </a:xfrm>
+          <a:prstGeom prst="rect">
+            <a:avLst/>
+          </a:prstGeom>
+        </p:spPr>
+      </p:pic>
+      <p:sp>
+        <p:nvSpPr>
+          <p:cNvPr id="121" name=""/>
+          <p:cNvSpPr>
+            <a:spLocks noGrp="1"/>
+          </p:cNvSpPr>
+          <p:nvPr/>
+        </p:nvSpPr>
+        <p:spPr>
+          <a:xfrm>
+            <a:off x="8950000" y="3930000"/>
+            <a:ext cx="2522862" cy="1100000"/>
+          </a:xfrm>
+          <a:prstGeom prst="rect">
+            <a:avLst/>
+          </a:prstGeom>
+          <a:noFill/>
+          <a:ln w="0">
+            <a:noFill/>
+            <a:prstDash val="solid"/>
+          </a:ln>
+        </p:spPr>
+        <p:txBody>
+          <a:bodyPr wrap="square" lIns="0" tIns="0" rIns="0" bIns="0" anchor="t">
+            <a:normAutofit fontScale="100000"/>
+          </a:bodyPr>
+          <a:lstStyle/>
+          <a:p>
+            <a:pPr algn="l">
+              <a:lnSpc>
+                <a:spcPct val="106000"/>
+              </a:lnSpc>
+              <a:buNone/>
+            </a:pPr>
+            <a:r>
+              <a:rPr sz="700" b="1" i="0">
+                <a:solidFill>
+                  <a:srgbClr val="9D4E24"/>
+                </a:solidFill>
+                <a:latin typeface="Arial"/>
+                <a:ea typeface="Arial"/>
+                <a:cs typeface="Arial"/>
+              </a:rPr>
+              <a:t>INDEPENDENT COVERAGE · FORBES · JUL 5, 2026</a:t>
+            </a:r>
+          </a:p>
+          <a:p>
+            <a:pPr algn="l">
+              <a:lnSpc>
+                <a:spcPct val="108000"/>
+              </a:lnSpc>
+              <a:buNone/>
+            </a:pPr>
+            <a:r>
+              <a:rPr sz="850" b="1" i="1" u="sng">
+                <a:solidFill>
+                  <a:srgbClr val="17191C"/>
+                </a:solidFill>
+                <a:latin typeface="Arial"/>
+                <a:ea typeface="Arial"/>
+                <a:cs typeface="Arial"/>
+                <a:hlinkClick r:id="Rforbes"/>
+              </a:rPr>
+              <a:t>“AI Data Centers Are Set To Electrify This $13 Billion Family’s 76-Year-Old Company”</a:t>
+            </a:r>
+          </a:p>
+          <a:p>
+            <a:pPr algn="l">
+              <a:lnSpc>
+                <a:spcPct val="120000"/>
+              </a:lnSpc>
+              <a:buNone/>
+            </a:pPr>
+            <a:r>
+              <a:rPr sz="750" b="1" i="0">
+                <a:solidFill>
+                  <a:srgbClr val="9D4E24"/>
+                </a:solidFill>
+                <a:latin typeface="Arial"/>
+                <a:ea typeface="Arial"/>
+                <a:cs typeface="Arial"/>
+                <a:hlinkClick r:id="Rforbes"/>
+              </a:rPr>
+              <a:t>READ ON FORBES ↗</a:t>
+            </a:r>
+          </a:p>
+        </p:txBody>
+      </p:sp>
+      <p:sp>
+        <p:nvSpPr>
+          <p:cNvPr id="122" name=""/>
+          <p:cNvSpPr>
+            <a:spLocks noGrp="1"/>
+          </p:cNvSpPr>
+          <p:nvPr/>
+        </p:nvSpPr>
+        <p:spPr>
+          <a:xfrm>
+            <a:off x="7300000" y="5080000"/>
+            <a:ext cx="4172862" cy="200000"/>
+          </a:xfrm>
+          <a:prstGeom prst="rect">
+            <a:avLst/>
+          </a:prstGeom>
+          <a:noFill/>
+          <a:ln w="0">
+            <a:noFill/>
+            <a:prstDash val="solid"/>
+          </a:ln>
+        </p:spPr>
+        <p:txBody>
+          <a:bodyPr wrap="square" lIns="0" tIns="0" rIns="0" bIns="0" anchor="t">
+            <a:normAutofit fontScale="100000"/>
+          </a:bodyPr>
+          <a:lstStyle/>
+          <a:p>
+            <a:pPr algn="l">
+              <a:lnSpc>
+                <a:spcPct val="100000"/>
+              </a:lnSpc>
+              <a:buNone/>
+            </a:pPr>
+            <a:r>
+              <a:rPr sz="650" b="0" i="1">
+                <a:solidFill>
+                  <a:srgbClr val="6A6F73"/>
+                </a:solidFill>
+                <a:latin typeface="Arial"/>
+                <a:ea typeface="Arial"/>
+                <a:cs typeface="Arial"/>
+              </a:rPr>
+              <a:t>Illustration: Macy Sinreich for Forbes; images: Getty Images.</a:t>
+            </a:r>
+          </a:p>
+        </p:txBody>
+      </p:sp>
+      <p:sp>
+        <p:nvSpPr>
+          <p:cNvPr id="123" name=""/>
+          <p:cNvSpPr>
+            <a:spLocks noGrp="1"/>
+          </p:cNvSpPr>
+          <p:nvPr/>
+        </p:nvSpPr>
+        <p:spPr>
+          <a:xfrm>
+            <a:off x="7300000" y="5420000"/>
+            <a:ext cx="4172862" cy="500000"/>
+          </a:xfrm>
+          <a:prstGeom prst="rect">
+            <a:avLst/>
+          </a:prstGeom>
+          <a:noFill/>
+          <a:ln w="0">
+            <a:noFill/>
+            <a:prstDash val="solid"/>
+          </a:ln>
+        </p:spPr>
+        <p:txBody>
+          <a:bodyPr wrap="square" lIns="0" tIns="0" rIns="0" bIns="0" anchor="t">
+            <a:normAutofit fontScale="100000"/>
+          </a:bodyPr>
+          <a:lstStyle/>
+          <a:p>
+            <a:pPr algn="l">
+              <a:lnSpc>
+                <a:spcPct val="106000"/>
+              </a:lnSpc>
+              <a:buNone/>
+            </a:pPr>
+            <a:r>
+              <a:rPr sz="850" b="1" i="0">
+                <a:solidFill>
+                  <a:srgbClr val="17191C"/>
+                </a:solidFill>
+                <a:latin typeface="Arial"/>
+                <a:ea typeface="Arial"/>
+                <a:cs typeface="Arial"/>
+              </a:rPr>
+              <a:t>Fact base: </a:t>
+            </a:r>
+            <a:r>
+              <a:rPr sz="850" b="0" i="0">
+                <a:solidFill>
+                  <a:srgbClr val="6A6F73"/>
+                </a:solidFill>
+                <a:latin typeface="Arial"/>
+                <a:ea typeface="Arial"/>
+                <a:cs typeface="Arial"/>
+              </a:rPr>
+              <a:t>NRG 2Q26 investor materials (Aug 4, 2026), PUCT / Texas Energy Fund announcements, Utility Dive coverage — as constrained by A2 and A5.</a:t>
+            </a:r>
+          </a:p>
+        </p:txBody>
+      </p:sp>
+      <p:sp>
+        <p:nvSpPr>
+          <p:cNvPr id="124" name=""/>
+          <p:cNvSpPr>
+            <a:spLocks noGrp="1"/>
+          </p:cNvSpPr>
+          <p:nvPr/>
+        </p:nvSpPr>
+        <p:spPr>
+          <a:xfrm>
+            <a:off x="719138" y="6315000"/>
+            <a:ext cx="10753724" cy="400000"/>
+          </a:xfrm>
+          <a:prstGeom prst="rect">
+            <a:avLst/>
+          </a:prstGeom>
+          <a:solidFill>
+            <a:srgbClr val="17191C"/>
+          </a:solidFill>
+          <a:ln w="0">
+            <a:noFill/>
+            <a:prstDash val="solid"/>
+          </a:ln>
+        </p:spPr>
+      </p:sp>
+      <p:sp>
+        <p:nvSpPr>
+          <p:cNvPr id="125" name=""/>
+          <p:cNvSpPr>
+            <a:spLocks noGrp="1"/>
+          </p:cNvSpPr>
+          <p:nvPr/>
+        </p:nvSpPr>
+        <p:spPr>
+          <a:xfrm>
+            <a:off x="719138" y="6315000"/>
+            <a:ext cx="10753724" cy="400000"/>
+          </a:xfrm>
+          <a:prstGeom prst="rect">
+            <a:avLst/>
+          </a:prstGeom>
+          <a:noFill/>
+          <a:ln w="0">
+            <a:noFill/>
+            <a:prstDash val="solid"/>
+          </a:ln>
+        </p:spPr>
+        <p:txBody>
+          <a:bodyPr wrap="square" lIns="0" tIns="0" rIns="0" bIns="0" anchor="ctr">
+            <a:normAutofit fontScale="100000"/>
+          </a:bodyPr>
+          <a:lstStyle/>
+          <a:p>
+            <a:pPr algn="ctr">
+              <a:lnSpc>
+                <a:spcPct val="100000"/>
+              </a:lnSpc>
+              <a:buNone/>
+            </a:pPr>
+            <a:r>
+              <a:rPr sz="880" b="1" i="0">
+                <a:solidFill>
+                  <a:srgbClr val="FFFFFF"/>
+                </a:solidFill>
+                <a:latin typeface="Arial"/>
+                <a:ea typeface="Arial"/>
+                <a:cs typeface="Arial"/>
+              </a:rPr>
+              <a:t>EVERY CLAIM IN THIS DECK TRACES TO ONE OF THESE DOCUMENTS — ASK AND WE WILL SEND THE SOURCE.</a:t>
             </a:r>
           </a:p>
         </p:txBody>

</xml_diff>